<commit_message>
Deployed bb54a27 with MkDocs version: 1.6.1
</commit_message>
<xml_diff>
--- a/tema2/diapositivas/persistencia-objetos-jsonb.pptx
+++ b/tema2/diapositivas/persistencia-objetos-jsonb.pptx
@@ -4,6 +4,9 @@
   <p:sldMasterIdLst>
     <p:sldMasterId id="2147483648" r:id="rId1"/>
   </p:sldMasterIdLst>
+  <p:notesMasterIdLst>
+    <p:notesMasterId r:id="rId21"/>
+  </p:notesMasterIdLst>
   <p:sldIdLst>
     <p:sldId id="256" r:id="rId2"/>
     <p:sldId id="257" r:id="rId3"/>
@@ -25,9 +28,6 @@
     <p:sldId id="273" r:id="rId19"/>
     <p:sldId id="274" r:id="rId20"/>
   </p:sldIdLst>
-  <p:notesMasterIdLst>
-    <p:notesMasterId r:id="rId21"/>
-  </p:notesMasterIdLst>
   <p:sldSz cx="12192000" cy="6858000"/>
   <p:notesSz cx="6858000" cy="12192000"/>
   <p:defaultTextStyle>
@@ -122,6 +122,11 @@
       </a:defRPr>
     </a:lvl9pPr>
   </p:defaultTextStyle>
+  <p:extLst>
+    <p:ext uri="{EFAFB233-063F-42B5-8137-9DF3F51BA10A}">
+      <p15:sldGuideLst xmlns:p15="http://schemas.microsoft.com/office/powerpoint/2012/main"/>
+    </p:ext>
+  </p:extLst>
 </p:presentation>
 </file>
 
@@ -147,234 +152,10 @@
           <a:chExt cx="0" cy="0"/>
         </a:xfrm>
       </p:grpSpPr>
-      <p:sp>
-        <p:nvSpPr>
-          <p:cNvPr id="2" name="Header Placeholder 1"/>
-          <p:cNvSpPr>
-            <a:spLocks noGrp="1"/>
-          </p:cNvSpPr>
-          <p:nvPr>
-            <p:ph type="hdr" sz="quarter"/>
-          </p:nvPr>
-        </p:nvSpPr>
-        <p:spPr>
-          <a:xfrm>
-            <a:off x="0" y="0"/>
-            <a:ext cx="2971800" cy="458788"/>
-          </a:xfrm>
-          <a:prstGeom prst="rect">
-            <a:avLst/>
-          </a:prstGeom>
-        </p:spPr>
-        <p:txBody>
-          <a:bodyPr vert="horz" lIns="91440" tIns="45720" rIns="91440" bIns="45720" rtlCol="0"/>
-          <a:lstStyle>
-            <a:lvl1pPr algn="l">
-              <a:defRPr sz="1200"/>
-            </a:lvl1pPr>
-          </a:lstStyle>
-          <a:p>
-            <a:endParaRPr lang="en-US"/>
-          </a:p>
-        </p:txBody>
-      </p:sp>
-      <p:sp>
-        <p:nvSpPr>
-          <p:cNvPr id="3" name="Date Placeholder 2"/>
-          <p:cNvSpPr>
-            <a:spLocks noGrp="1"/>
-          </p:cNvSpPr>
-          <p:nvPr>
-            <p:ph type="dt" idx="1"/>
-          </p:nvPr>
-        </p:nvSpPr>
-        <p:spPr>
-          <a:xfrm>
-            <a:off x="3884613" y="0"/>
-            <a:ext cx="2971800" cy="458788"/>
-          </a:xfrm>
-          <a:prstGeom prst="rect">
-            <a:avLst/>
-          </a:prstGeom>
-        </p:spPr>
-        <p:txBody>
-          <a:bodyPr vert="horz" lIns="91440" tIns="45720" rIns="91440" bIns="45720" rtlCol="0"/>
-          <a:lstStyle>
-            <a:lvl1pPr algn="r">
-              <a:defRPr sz="1200"/>
-            </a:lvl1pPr>
-          </a:lstStyle>
-          <a:p>
-            <a:fld id="{5282F153-3F37-0F45-9E97-73ACFA13230C}" type="datetimeFigureOut">
-              <a:rPr lang="en-US"/>
-              <a:t>7/23/19</a:t>
-            </a:fld>
-            <a:endParaRPr lang="en-US"/>
-          </a:p>
-        </p:txBody>
-      </p:sp>
-      <p:sp>
-        <p:nvSpPr>
-          <p:cNvPr id="4" name="Slide Image Placeholder 3"/>
-          <p:cNvSpPr>
-            <a:spLocks noGrp="1" noRot="1" noChangeAspect="1"/>
-          </p:cNvSpPr>
-          <p:nvPr>
-            <p:ph type="sldImg" idx="2"/>
-          </p:nvPr>
-        </p:nvSpPr>
-        <p:spPr>
-          <a:xfrm>
-            <a:off x="685800" y="1143000"/>
-            <a:ext cx="5486400" cy="3086100"/>
-          </a:xfrm>
-          <a:prstGeom prst="rect">
-            <a:avLst/>
-          </a:prstGeom>
-          <a:noFill/>
-          <a:ln w="12700">
-            <a:solidFill>
-              <a:prstClr val="black"/>
-            </a:solidFill>
-          </a:ln>
-        </p:spPr>
-        <p:txBody>
-          <a:bodyPr vert="horz" lIns="91440" tIns="45720" rIns="91440" bIns="45720" rtlCol="0" anchor="ctr"/>
-          <a:lstStyle/>
-          <a:p>
-            <a:endParaRPr lang="en-US"/>
-          </a:p>
-        </p:txBody>
-      </p:sp>
-      <p:sp>
-        <p:nvSpPr>
-          <p:cNvPr id="5" name="Notes Placeholder 4"/>
-          <p:cNvSpPr>
-            <a:spLocks noGrp="1"/>
-          </p:cNvSpPr>
-          <p:nvPr>
-            <p:ph type="body" sz="quarter" idx="3"/>
-          </p:nvPr>
-        </p:nvSpPr>
-        <p:spPr>
-          <a:xfrm>
-            <a:off x="685800" y="4400550"/>
-            <a:ext cx="5486400" cy="3600450"/>
-          </a:xfrm>
-          <a:prstGeom prst="rect">
-            <a:avLst/>
-          </a:prstGeom>
-        </p:spPr>
-        <p:txBody>
-          <a:bodyPr vert="horz" lIns="91440" tIns="45720" rIns="91440" bIns="45720" rtlCol="0"/>
-          <a:lstStyle/>
-          <a:p>
-            <a:pPr lvl="0"/>
-            <a:r>
-              <a:rPr lang="en-US"/>
-              <a:t>Click to edit Master text styles</a:t>
-            </a:r>
-          </a:p>
-          <a:p>
-            <a:pPr lvl="1"/>
-            <a:r>
-              <a:rPr lang="en-US"/>
-              <a:t>Second level</a:t>
-            </a:r>
-          </a:p>
-          <a:p>
-            <a:pPr lvl="2"/>
-            <a:r>
-              <a:rPr lang="en-US"/>
-              <a:t>Third level</a:t>
-            </a:r>
-          </a:p>
-          <a:p>
-            <a:pPr lvl="3"/>
-            <a:r>
-              <a:rPr lang="en-US"/>
-              <a:t>Fourth level</a:t>
-            </a:r>
-          </a:p>
-          <a:p>
-            <a:pPr lvl="4"/>
-            <a:r>
-              <a:rPr lang="en-US"/>
-              <a:t>Fifth level</a:t>
-            </a:r>
-          </a:p>
-        </p:txBody>
-      </p:sp>
-      <p:sp>
-        <p:nvSpPr>
-          <p:cNvPr id="6" name="Footer Placeholder 5"/>
-          <p:cNvSpPr>
-            <a:spLocks noGrp="1"/>
-          </p:cNvSpPr>
-          <p:nvPr>
-            <p:ph type="ftr" sz="quarter" idx="4"/>
-          </p:nvPr>
-        </p:nvSpPr>
-        <p:spPr>
-          <a:xfrm>
-            <a:off x="0" y="8685213"/>
-            <a:ext cx="2971800" cy="458787"/>
-          </a:xfrm>
-          <a:prstGeom prst="rect">
-            <a:avLst/>
-          </a:prstGeom>
-        </p:spPr>
-        <p:txBody>
-          <a:bodyPr vert="horz" lIns="91440" tIns="45720" rIns="91440" bIns="45720" rtlCol="0" anchor="b"/>
-          <a:lstStyle>
-            <a:lvl1pPr algn="l">
-              <a:defRPr sz="1200"/>
-            </a:lvl1pPr>
-          </a:lstStyle>
-          <a:p>
-            <a:endParaRPr lang="en-US"/>
-          </a:p>
-        </p:txBody>
-      </p:sp>
-      <p:sp>
-        <p:nvSpPr>
-          <p:cNvPr id="7" name="Slide Number Placeholder 6"/>
-          <p:cNvSpPr>
-            <a:spLocks noGrp="1"/>
-          </p:cNvSpPr>
-          <p:nvPr>
-            <p:ph type="sldNum" sz="quarter" idx="5"/>
-          </p:nvPr>
-        </p:nvSpPr>
-        <p:spPr>
-          <a:xfrm>
-            <a:off x="3884613" y="8685213"/>
-            <a:ext cx="2971800" cy="458787"/>
-          </a:xfrm>
-          <a:prstGeom prst="rect">
-            <a:avLst/>
-          </a:prstGeom>
-        </p:spPr>
-        <p:txBody>
-          <a:bodyPr vert="horz" lIns="91440" tIns="45720" rIns="91440" bIns="45720" rtlCol="0" anchor="b"/>
-          <a:lstStyle>
-            <a:lvl1pPr algn="r">
-              <a:defRPr sz="1200"/>
-            </a:lvl1pPr>
-          </a:lstStyle>
-          <a:p>
-            <a:fld id="{CE5E9CC1-C706-0F49-92D6-E571CC5EEA8F}" type="slidenum">
-              <a:rPr lang="en-US"/>
-              <a:t>‹#›</a:t>
-            </a:fld>
-            <a:endParaRPr lang="en-US"/>
-          </a:p>
-        </p:txBody>
-      </p:sp>
     </p:spTree>
     <p:extLst>
       <p:ext uri="{BB962C8B-B14F-4D97-AF65-F5344CB8AC3E}">
-        <p14:creationId xmlns:p14="http://schemas.microsoft.com/office/powerpoint/2010/main" val="1024086991"/>
+        <p14:creationId xmlns:p14="http://schemas.microsoft.com/office/powerpoint/2010/main" val="4113021911"/>
       </p:ext>
     </p:extLst>
   </p:cSld>
@@ -518,10 +299,6 @@
           <a:bodyPr/>
           <a:lstStyle/>
           <a:p>
-            <a:r>
-              <a:rPr lang="en-US" dirty="0"/>
-              <a:t/>
-            </a:r>
             <a:endParaRPr lang="en-US" dirty="0"/>
           </a:p>
         </p:txBody>
@@ -606,10 +383,6 @@
           <a:bodyPr/>
           <a:lstStyle/>
           <a:p>
-            <a:r>
-              <a:rPr lang="en-US" dirty="0"/>
-              <a:t/>
-            </a:r>
             <a:endParaRPr lang="en-US" dirty="0"/>
           </a:p>
         </p:txBody>
@@ -694,10 +467,6 @@
           <a:bodyPr/>
           <a:lstStyle/>
           <a:p>
-            <a:r>
-              <a:rPr lang="en-US" dirty="0"/>
-              <a:t/>
-            </a:r>
             <a:endParaRPr lang="en-US" dirty="0"/>
           </a:p>
         </p:txBody>
@@ -782,10 +551,6 @@
           <a:bodyPr/>
           <a:lstStyle/>
           <a:p>
-            <a:r>
-              <a:rPr lang="en-US" dirty="0"/>
-              <a:t/>
-            </a:r>
             <a:endParaRPr lang="en-US" dirty="0"/>
           </a:p>
         </p:txBody>
@@ -870,10 +635,6 @@
           <a:bodyPr/>
           <a:lstStyle/>
           <a:p>
-            <a:r>
-              <a:rPr lang="en-US" dirty="0"/>
-              <a:t/>
-            </a:r>
             <a:endParaRPr lang="en-US" dirty="0"/>
           </a:p>
         </p:txBody>
@@ -958,10 +719,6 @@
           <a:bodyPr/>
           <a:lstStyle/>
           <a:p>
-            <a:r>
-              <a:rPr lang="en-US" dirty="0"/>
-              <a:t/>
-            </a:r>
             <a:endParaRPr lang="en-US" dirty="0"/>
           </a:p>
         </p:txBody>
@@ -1046,10 +803,6 @@
           <a:bodyPr/>
           <a:lstStyle/>
           <a:p>
-            <a:r>
-              <a:rPr lang="en-US" dirty="0"/>
-              <a:t/>
-            </a:r>
             <a:endParaRPr lang="en-US" dirty="0"/>
           </a:p>
         </p:txBody>
@@ -1134,10 +887,6 @@
           <a:bodyPr/>
           <a:lstStyle/>
           <a:p>
-            <a:r>
-              <a:rPr lang="en-US" dirty="0"/>
-              <a:t/>
-            </a:r>
             <a:endParaRPr lang="en-US" dirty="0"/>
           </a:p>
         </p:txBody>
@@ -1222,10 +971,6 @@
           <a:bodyPr/>
           <a:lstStyle/>
           <a:p>
-            <a:r>
-              <a:rPr lang="en-US" dirty="0"/>
-              <a:t/>
-            </a:r>
             <a:endParaRPr lang="en-US" dirty="0"/>
           </a:p>
         </p:txBody>
@@ -1310,10 +1055,6 @@
           <a:bodyPr/>
           <a:lstStyle/>
           <a:p>
-            <a:r>
-              <a:rPr lang="en-US" dirty="0"/>
-              <a:t/>
-            </a:r>
             <a:endParaRPr lang="en-US" dirty="0"/>
           </a:p>
         </p:txBody>
@@ -1398,10 +1139,6 @@
           <a:bodyPr/>
           <a:lstStyle/>
           <a:p>
-            <a:r>
-              <a:rPr lang="en-US" dirty="0"/>
-              <a:t/>
-            </a:r>
             <a:endParaRPr lang="en-US" dirty="0"/>
           </a:p>
         </p:txBody>
@@ -1486,10 +1223,6 @@
           <a:bodyPr/>
           <a:lstStyle/>
           <a:p>
-            <a:r>
-              <a:rPr lang="en-US" dirty="0"/>
-              <a:t/>
-            </a:r>
             <a:endParaRPr lang="en-US" dirty="0"/>
           </a:p>
         </p:txBody>
@@ -1574,10 +1307,6 @@
           <a:bodyPr/>
           <a:lstStyle/>
           <a:p>
-            <a:r>
-              <a:rPr lang="en-US" dirty="0"/>
-              <a:t/>
-            </a:r>
             <a:endParaRPr lang="en-US" dirty="0"/>
           </a:p>
         </p:txBody>
@@ -1662,10 +1391,6 @@
           <a:bodyPr/>
           <a:lstStyle/>
           <a:p>
-            <a:r>
-              <a:rPr lang="en-US" dirty="0"/>
-              <a:t/>
-            </a:r>
             <a:endParaRPr lang="en-US" dirty="0"/>
           </a:p>
         </p:txBody>
@@ -1750,10 +1475,6 @@
           <a:bodyPr/>
           <a:lstStyle/>
           <a:p>
-            <a:r>
-              <a:rPr lang="en-US" dirty="0"/>
-              <a:t/>
-            </a:r>
             <a:endParaRPr lang="en-US" dirty="0"/>
           </a:p>
         </p:txBody>
@@ -1838,10 +1559,6 @@
           <a:bodyPr/>
           <a:lstStyle/>
           <a:p>
-            <a:r>
-              <a:rPr lang="en-US" dirty="0"/>
-              <a:t/>
-            </a:r>
             <a:endParaRPr lang="en-US" dirty="0"/>
           </a:p>
         </p:txBody>
@@ -1926,10 +1643,6 @@
           <a:bodyPr/>
           <a:lstStyle/>
           <a:p>
-            <a:r>
-              <a:rPr lang="en-US" dirty="0"/>
-              <a:t/>
-            </a:r>
             <a:endParaRPr lang="en-US" dirty="0"/>
           </a:p>
         </p:txBody>
@@ -2014,10 +1727,6 @@
           <a:bodyPr/>
           <a:lstStyle/>
           <a:p>
-            <a:r>
-              <a:rPr lang="en-US" dirty="0"/>
-              <a:t/>
-            </a:r>
             <a:endParaRPr lang="en-US" dirty="0"/>
           </a:p>
         </p:txBody>
@@ -2102,10 +1811,6 @@
           <a:bodyPr/>
           <a:lstStyle/>
           <a:p>
-            <a:r>
-              <a:rPr lang="en-US" dirty="0"/>
-              <a:t/>
-            </a:r>
             <a:endParaRPr lang="en-US" dirty="0"/>
           </a:p>
         </p:txBody>
@@ -2179,6 +1884,11 @@
 <file path=ppt/slideMasters/slideMaster1.xml><?xml version="1.0" encoding="utf-8"?>
 <p:sldMaster xmlns:a="http://schemas.openxmlformats.org/drawingml/2006/main" xmlns:r="http://schemas.openxmlformats.org/officeDocument/2006/relationships" xmlns:p="http://schemas.openxmlformats.org/presentationml/2006/main">
   <p:cSld>
+    <p:bg>
+      <p:bgRef idx="1001">
+        <a:schemeClr val="bg1"/>
+      </p:bgRef>
+    </p:bg>
     <p:spTree>
       <p:nvGrpSpPr>
         <p:cNvPr id="1" name=""/>
@@ -2461,6 +2171,7 @@
         <a:solidFill>
           <a:srgbClr val="7F0000"/>
         </a:solidFill>
+        <a:effectLst/>
       </p:bgPr>
     </p:bg>
     <p:spTree>
@@ -2498,7 +2209,7 @@
           <a:bodyPr wrap="square" rtlCol="0" anchor="ctr"/>
           <a:lstStyle/>
           <a:p>
-            <a:pPr indent="0" marL="0">
+            <a:pPr marL="0" indent="0">
               <a:buNone/>
             </a:pPr>
             <a:r>
@@ -2537,7 +2248,7 @@
           <a:bodyPr wrap="square" rtlCol="0" anchor="ctr"/>
           <a:lstStyle/>
           <a:p>
-            <a:pPr algn="l" indent="0" marL="0">
+            <a:pPr marL="0" indent="0" algn="l">
               <a:buNone/>
             </a:pPr>
             <a:r>
@@ -2554,7 +2265,7 @@
             <a:endParaRPr lang="en-US" sz="3800" dirty="0"/>
           </a:p>
           <a:p>
-            <a:pPr algn="l" indent="0" marL="0">
+            <a:pPr marL="0" indent="0" algn="l">
               <a:buNone/>
             </a:pPr>
             <a:r>
@@ -2596,6 +2307,13 @@
             <a:prstDash val="solid"/>
           </a:ln>
         </p:spPr>
+        <p:txBody>
+          <a:bodyPr/>
+          <a:lstStyle/>
+          <a:p>
+            <a:endParaRPr lang="es-ES"/>
+          </a:p>
+        </p:txBody>
       </p:sp>
       <p:sp>
         <p:nvSpPr>
@@ -2618,7 +2336,7 @@
           <a:bodyPr wrap="square" rtlCol="0" anchor="ctr"/>
           <a:lstStyle/>
           <a:p>
-            <a:pPr indent="0" marL="0">
+            <a:pPr marL="0" indent="0">
               <a:buNone/>
             </a:pPr>
             <a:r>
@@ -2685,6 +2403,13 @@
             <a:prstDash val="solid"/>
           </a:ln>
         </p:spPr>
+        <p:txBody>
+          <a:bodyPr/>
+          <a:lstStyle/>
+          <a:p>
+            <a:endParaRPr lang="es-ES"/>
+          </a:p>
+        </p:txBody>
       </p:sp>
       <p:sp>
         <p:nvSpPr>
@@ -2707,7 +2432,7 @@
           <a:bodyPr wrap="square" rtlCol="0" anchor="ctr"/>
           <a:lstStyle/>
           <a:p>
-            <a:pPr indent="0" marL="0">
+            <a:pPr marL="0" indent="0">
               <a:buNone/>
             </a:pPr>
             <a:r>
@@ -2746,7 +2471,7 @@
           <a:bodyPr wrap="square" rtlCol="0" anchor="ctr"/>
           <a:lstStyle/>
           <a:p>
-            <a:pPr algn="r" indent="0" marL="0">
+            <a:pPr marL="0" indent="0" algn="r">
               <a:buNone/>
             </a:pPr>
             <a:r>
@@ -2788,6 +2513,13 @@
             <a:prstDash val="solid"/>
           </a:ln>
         </p:spPr>
+        <p:txBody>
+          <a:bodyPr/>
+          <a:lstStyle/>
+          <a:p>
+            <a:endParaRPr lang="es-ES"/>
+          </a:p>
+        </p:txBody>
       </p:sp>
       <p:sp>
         <p:nvSpPr>
@@ -2810,7 +2542,7 @@
           <a:bodyPr wrap="square" rtlCol="0" anchor="ctr"/>
           <a:lstStyle/>
           <a:p>
-            <a:pPr indent="0" marL="0">
+            <a:pPr marL="0" indent="0">
               <a:buNone/>
             </a:pPr>
             <a:r>
@@ -2849,7 +2581,7 @@
           <a:bodyPr wrap="square" rtlCol="0" anchor="t"/>
           <a:lstStyle/>
           <a:p>
-            <a:pPr indent="0" marL="0">
+            <a:pPr marL="0" indent="0">
               <a:buNone/>
             </a:pPr>
             <a:r>
@@ -2916,6 +2648,13 @@
             <a:prstDash val="solid"/>
           </a:ln>
         </p:spPr>
+        <p:txBody>
+          <a:bodyPr/>
+          <a:lstStyle/>
+          <a:p>
+            <a:endParaRPr lang="es-ES"/>
+          </a:p>
+        </p:txBody>
       </p:sp>
       <p:sp>
         <p:nvSpPr>
@@ -2938,7 +2677,7 @@
           <a:bodyPr wrap="square" rtlCol="0" anchor="ctr"/>
           <a:lstStyle/>
           <a:p>
-            <a:pPr indent="0" marL="0">
+            <a:pPr marL="0" indent="0">
               <a:buNone/>
             </a:pPr>
             <a:r>
@@ -2977,7 +2716,7 @@
           <a:bodyPr wrap="square" rtlCol="0" anchor="ctr"/>
           <a:lstStyle/>
           <a:p>
-            <a:pPr algn="r" indent="0" marL="0">
+            <a:pPr marL="0" indent="0" algn="r">
               <a:buNone/>
             </a:pPr>
             <a:r>
@@ -3016,7 +2755,7 @@
           <a:bodyPr wrap="square" rtlCol="0" anchor="t"/>
           <a:lstStyle/>
           <a:p>
-            <a:pPr indent="0" marL="0">
+            <a:pPr marL="0" indent="0">
               <a:buNone/>
             </a:pPr>
             <a:r>
@@ -3050,16 +2789,34 @@
         </p:nvGraphicFramePr>
         <p:xfrm>
           <a:off x="548640" y="2057400"/>
-          <a:ext cx="11091672" cy="914400"/>
+          <a:ext cx="11091672" cy="3291840"/>
         </p:xfrm>
         <a:graphic>
           <a:graphicData uri="http://schemas.openxmlformats.org/drawingml/2006/table">
             <a:tbl>
               <a:tblPr/>
               <a:tblGrid>
-                <a:gridCol w="2440168"/>
-                <a:gridCol w="4325752"/>
-                <a:gridCol w="4325752"/>
+                <a:gridCol w="2440168">
+                  <a:extLst>
+                    <a:ext uri="{9D8B030D-6E8A-4147-A177-3AD203B41FA5}">
+                      <a16:colId xmlns:a16="http://schemas.microsoft.com/office/drawing/2014/main" val="20000"/>
+                    </a:ext>
+                  </a:extLst>
+                </a:gridCol>
+                <a:gridCol w="4325752">
+                  <a:extLst>
+                    <a:ext uri="{9D8B030D-6E8A-4147-A177-3AD203B41FA5}">
+                      <a16:colId xmlns:a16="http://schemas.microsoft.com/office/drawing/2014/main" val="20001"/>
+                    </a:ext>
+                  </a:extLst>
+                </a:gridCol>
+                <a:gridCol w="4325752">
+                  <a:extLst>
+                    <a:ext uri="{9D8B030D-6E8A-4147-A177-3AD203B41FA5}">
+                      <a16:colId xmlns:a16="http://schemas.microsoft.com/office/drawing/2014/main" val="20002"/>
+                    </a:ext>
+                  </a:extLst>
+                </a:gridCol>
               </a:tblGrid>
               <a:tr h="658368">
                 <a:tc>
@@ -3067,7 +2824,7 @@
                     <a:bodyPr/>
                     <a:lstStyle/>
                     <a:p>
-                      <a:pPr algn="ctr" indent="0" marL="0">
+                      <a:pPr marL="0" indent="0" algn="ctr">
                         <a:buNone/>
                       </a:pPr>
                       <a:endParaRPr lang="en-US" sz="1500" dirty="0">
@@ -3077,7 +2834,7 @@
                       </a:endParaRPr>
                     </a:p>
                   </a:txBody>
-                  <a:tcPr marL="91440" marR="91440" marT="45720" marB="45720" anchor="ctr">
+                  <a:tcPr anchor="ctr">
                     <a:lnL w="12700" cap="flat" cmpd="sng" algn="ctr">
                       <a:solidFill>
                         <a:srgbClr val="EEEEEE"/>
@@ -3124,7 +2881,7 @@
                     <a:bodyPr/>
                     <a:lstStyle/>
                     <a:p>
-                      <a:pPr algn="ctr" indent="0" marL="0">
+                      <a:pPr marL="0" indent="0" algn="ctr">
                         <a:buNone/>
                       </a:pPr>
                       <a:r>
@@ -3145,7 +2902,7 @@
                       </a:endParaRPr>
                     </a:p>
                   </a:txBody>
-                  <a:tcPr marL="91440" marR="91440" marT="45720" marB="45720" anchor="ctr">
+                  <a:tcPr anchor="ctr">
                     <a:lnL w="12700" cap="flat" cmpd="sng" algn="ctr">
                       <a:solidFill>
                         <a:srgbClr val="EEEEEE"/>
@@ -3192,7 +2949,7 @@
                     <a:bodyPr/>
                     <a:lstStyle/>
                     <a:p>
-                      <a:pPr algn="ctr" indent="0" marL="0">
+                      <a:pPr marL="0" indent="0" algn="ctr">
                         <a:buNone/>
                       </a:pPr>
                       <a:r>
@@ -3213,7 +2970,7 @@
                       </a:endParaRPr>
                     </a:p>
                   </a:txBody>
-                  <a:tcPr marL="91440" marR="91440" marT="45720" marB="45720" anchor="ctr">
+                  <a:tcPr anchor="ctr">
                     <a:lnL w="12700" cap="flat" cmpd="sng" algn="ctr">
                       <a:solidFill>
                         <a:srgbClr val="EEEEEE"/>
@@ -3255,6 +3012,11 @@
                     </a:solidFill>
                   </a:tcPr>
                 </a:tc>
+                <a:extLst>
+                  <a:ext uri="{0D108BD9-81ED-4DB2-BD59-A6C34878D82A}">
+                    <a16:rowId xmlns:a16="http://schemas.microsoft.com/office/drawing/2014/main" val="10000"/>
+                  </a:ext>
+                </a:extLst>
               </a:tr>
               <a:tr h="658368">
                 <a:tc>
@@ -3262,7 +3024,7 @@
                     <a:bodyPr/>
                     <a:lstStyle/>
                     <a:p>
-                      <a:pPr indent="0" marL="0">
+                      <a:pPr marL="0" indent="0">
                         <a:buNone/>
                       </a:pPr>
                       <a:r>
@@ -3283,7 +3045,7 @@
                       </a:endParaRPr>
                     </a:p>
                   </a:txBody>
-                  <a:tcPr marL="91440" marR="91440" marT="45720" marB="45720" anchor="ctr">
+                  <a:tcPr anchor="ctr">
                     <a:lnL w="12700" cap="flat" cmpd="sng" algn="ctr">
                       <a:solidFill>
                         <a:srgbClr val="EEEEEE"/>
@@ -3330,7 +3092,7 @@
                     <a:bodyPr/>
                     <a:lstStyle/>
                     <a:p>
-                      <a:pPr indent="0" marL="0">
+                      <a:pPr marL="0" indent="0">
                         <a:buNone/>
                       </a:pPr>
                       <a:r>
@@ -3351,7 +3113,7 @@
                       </a:endParaRPr>
                     </a:p>
                   </a:txBody>
-                  <a:tcPr marL="91440" marR="91440" marT="45720" marB="45720" anchor="ctr">
+                  <a:tcPr anchor="ctr">
                     <a:lnL w="12700" cap="flat" cmpd="sng" algn="ctr">
                       <a:solidFill>
                         <a:srgbClr val="EEEEEE"/>
@@ -3398,7 +3160,7 @@
                     <a:bodyPr/>
                     <a:lstStyle/>
                     <a:p>
-                      <a:pPr indent="0" marL="0">
+                      <a:pPr marL="0" indent="0">
                         <a:buNone/>
                       </a:pPr>
                       <a:r>
@@ -3419,7 +3181,7 @@
                       </a:endParaRPr>
                     </a:p>
                   </a:txBody>
-                  <a:tcPr marL="91440" marR="91440" marT="45720" marB="45720" anchor="ctr">
+                  <a:tcPr anchor="ctr">
                     <a:lnL w="12700" cap="flat" cmpd="sng" algn="ctr">
                       <a:solidFill>
                         <a:srgbClr val="EEEEEE"/>
@@ -3461,6 +3223,11 @@
                     </a:solidFill>
                   </a:tcPr>
                 </a:tc>
+                <a:extLst>
+                  <a:ext uri="{0D108BD9-81ED-4DB2-BD59-A6C34878D82A}">
+                    <a16:rowId xmlns:a16="http://schemas.microsoft.com/office/drawing/2014/main" val="10001"/>
+                  </a:ext>
+                </a:extLst>
               </a:tr>
               <a:tr h="658368">
                 <a:tc>
@@ -3468,7 +3235,7 @@
                     <a:bodyPr/>
                     <a:lstStyle/>
                     <a:p>
-                      <a:pPr indent="0" marL="0">
+                      <a:pPr marL="0" indent="0">
                         <a:buNone/>
                       </a:pPr>
                       <a:r>
@@ -3489,7 +3256,7 @@
                       </a:endParaRPr>
                     </a:p>
                   </a:txBody>
-                  <a:tcPr marL="91440" marR="91440" marT="45720" marB="45720" anchor="ctr">
+                  <a:tcPr anchor="ctr">
                     <a:lnL w="12700" cap="flat" cmpd="sng" algn="ctr">
                       <a:solidFill>
                         <a:srgbClr val="EEEEEE"/>
@@ -3536,7 +3303,7 @@
                     <a:bodyPr/>
                     <a:lstStyle/>
                     <a:p>
-                      <a:pPr indent="0" marL="0">
+                      <a:pPr marL="0" indent="0">
                         <a:buNone/>
                       </a:pPr>
                       <a:r>
@@ -3557,7 +3324,7 @@
                       </a:endParaRPr>
                     </a:p>
                   </a:txBody>
-                  <a:tcPr marL="91440" marR="91440" marT="45720" marB="45720" anchor="ctr">
+                  <a:tcPr anchor="ctr">
                     <a:lnL w="12700" cap="flat" cmpd="sng" algn="ctr">
                       <a:solidFill>
                         <a:srgbClr val="EEEEEE"/>
@@ -3604,7 +3371,7 @@
                     <a:bodyPr/>
                     <a:lstStyle/>
                     <a:p>
-                      <a:pPr indent="0" marL="0">
+                      <a:pPr marL="0" indent="0">
                         <a:buNone/>
                       </a:pPr>
                       <a:r>
@@ -3625,7 +3392,7 @@
                       </a:endParaRPr>
                     </a:p>
                   </a:txBody>
-                  <a:tcPr marL="91440" marR="91440" marT="45720" marB="45720" anchor="ctr">
+                  <a:tcPr anchor="ctr">
                     <a:lnL w="12700" cap="flat" cmpd="sng" algn="ctr">
                       <a:solidFill>
                         <a:srgbClr val="EEEEEE"/>
@@ -3667,6 +3434,11 @@
                     </a:solidFill>
                   </a:tcPr>
                 </a:tc>
+                <a:extLst>
+                  <a:ext uri="{0D108BD9-81ED-4DB2-BD59-A6C34878D82A}">
+                    <a16:rowId xmlns:a16="http://schemas.microsoft.com/office/drawing/2014/main" val="10002"/>
+                  </a:ext>
+                </a:extLst>
               </a:tr>
               <a:tr h="658368">
                 <a:tc>
@@ -3674,7 +3446,7 @@
                     <a:bodyPr/>
                     <a:lstStyle/>
                     <a:p>
-                      <a:pPr indent="0" marL="0">
+                      <a:pPr marL="0" indent="0">
                         <a:buNone/>
                       </a:pPr>
                       <a:r>
@@ -3695,7 +3467,7 @@
                       </a:endParaRPr>
                     </a:p>
                   </a:txBody>
-                  <a:tcPr marL="91440" marR="91440" marT="45720" marB="45720" anchor="ctr">
+                  <a:tcPr anchor="ctr">
                     <a:lnL w="12700" cap="flat" cmpd="sng" algn="ctr">
                       <a:solidFill>
                         <a:srgbClr val="EEEEEE"/>
@@ -3742,7 +3514,7 @@
                     <a:bodyPr/>
                     <a:lstStyle/>
                     <a:p>
-                      <a:pPr indent="0" marL="0">
+                      <a:pPr marL="0" indent="0">
                         <a:buNone/>
                       </a:pPr>
                       <a:r>
@@ -3763,7 +3535,7 @@
                       </a:endParaRPr>
                     </a:p>
                   </a:txBody>
-                  <a:tcPr marL="91440" marR="91440" marT="45720" marB="45720" anchor="ctr">
+                  <a:tcPr anchor="ctr">
                     <a:lnL w="12700" cap="flat" cmpd="sng" algn="ctr">
                       <a:solidFill>
                         <a:srgbClr val="EEEEEE"/>
@@ -3810,7 +3582,7 @@
                     <a:bodyPr/>
                     <a:lstStyle/>
                     <a:p>
-                      <a:pPr indent="0" marL="0">
+                      <a:pPr marL="0" indent="0">
                         <a:buNone/>
                       </a:pPr>
                       <a:r>
@@ -3831,7 +3603,7 @@
                       </a:endParaRPr>
                     </a:p>
                   </a:txBody>
-                  <a:tcPr marL="91440" marR="91440" marT="45720" marB="45720" anchor="ctr">
+                  <a:tcPr anchor="ctr">
                     <a:lnL w="12700" cap="flat" cmpd="sng" algn="ctr">
                       <a:solidFill>
                         <a:srgbClr val="EEEEEE"/>
@@ -3873,6 +3645,11 @@
                     </a:solidFill>
                   </a:tcPr>
                 </a:tc>
+                <a:extLst>
+                  <a:ext uri="{0D108BD9-81ED-4DB2-BD59-A6C34878D82A}">
+                    <a16:rowId xmlns:a16="http://schemas.microsoft.com/office/drawing/2014/main" val="10003"/>
+                  </a:ext>
+                </a:extLst>
               </a:tr>
               <a:tr h="658368">
                 <a:tc>
@@ -3880,7 +3657,7 @@
                     <a:bodyPr/>
                     <a:lstStyle/>
                     <a:p>
-                      <a:pPr indent="0" marL="0">
+                      <a:pPr marL="0" indent="0">
                         <a:buNone/>
                       </a:pPr>
                       <a:r>
@@ -3901,7 +3678,7 @@
                       </a:endParaRPr>
                     </a:p>
                   </a:txBody>
-                  <a:tcPr marL="91440" marR="91440" marT="45720" marB="45720" anchor="ctr">
+                  <a:tcPr anchor="ctr">
                     <a:lnL w="12700" cap="flat" cmpd="sng" algn="ctr">
                       <a:solidFill>
                         <a:srgbClr val="EEEEEE"/>
@@ -3948,7 +3725,7 @@
                     <a:bodyPr/>
                     <a:lstStyle/>
                     <a:p>
-                      <a:pPr indent="0" marL="0">
+                      <a:pPr marL="0" indent="0">
                         <a:buNone/>
                       </a:pPr>
                       <a:r>
@@ -3969,7 +3746,7 @@
                       </a:endParaRPr>
                     </a:p>
                   </a:txBody>
-                  <a:tcPr marL="91440" marR="91440" marT="45720" marB="45720" anchor="ctr">
+                  <a:tcPr anchor="ctr">
                     <a:lnL w="12700" cap="flat" cmpd="sng" algn="ctr">
                       <a:solidFill>
                         <a:srgbClr val="EEEEEE"/>
@@ -4016,7 +3793,7 @@
                     <a:bodyPr/>
                     <a:lstStyle/>
                     <a:p>
-                      <a:pPr indent="0" marL="0">
+                      <a:pPr marL="0" indent="0">
                         <a:buNone/>
                       </a:pPr>
                       <a:r>
@@ -4037,7 +3814,7 @@
                       </a:endParaRPr>
                     </a:p>
                   </a:txBody>
-                  <a:tcPr marL="91440" marR="91440" marT="45720" marB="45720" anchor="ctr">
+                  <a:tcPr anchor="ctr">
                     <a:lnL w="12700" cap="flat" cmpd="sng" algn="ctr">
                       <a:solidFill>
                         <a:srgbClr val="EEEEEE"/>
@@ -4079,6 +3856,11 @@
                     </a:solidFill>
                   </a:tcPr>
                 </a:tc>
+                <a:extLst>
+                  <a:ext uri="{0D108BD9-81ED-4DB2-BD59-A6C34878D82A}">
+                    <a16:rowId xmlns:a16="http://schemas.microsoft.com/office/drawing/2014/main" val="10004"/>
+                  </a:ext>
+                </a:extLst>
               </a:tr>
             </a:tbl>
           </a:graphicData>
@@ -4133,6 +3915,13 @@
             <a:prstDash val="solid"/>
           </a:ln>
         </p:spPr>
+        <p:txBody>
+          <a:bodyPr/>
+          <a:lstStyle/>
+          <a:p>
+            <a:endParaRPr lang="es-ES"/>
+          </a:p>
+        </p:txBody>
       </p:sp>
       <p:sp>
         <p:nvSpPr>
@@ -4155,7 +3944,7 @@
           <a:bodyPr wrap="square" rtlCol="0" anchor="ctr"/>
           <a:lstStyle/>
           <a:p>
-            <a:pPr indent="0" marL="0">
+            <a:pPr marL="0" indent="0">
               <a:buNone/>
             </a:pPr>
             <a:r>
@@ -4194,7 +3983,7 @@
           <a:bodyPr wrap="square" rtlCol="0" anchor="ctr"/>
           <a:lstStyle/>
           <a:p>
-            <a:pPr algn="r" indent="0" marL="0">
+            <a:pPr marL="0" indent="0" algn="r">
               <a:buNone/>
             </a:pPr>
             <a:r>
@@ -4236,6 +4025,13 @@
             <a:prstDash val="solid"/>
           </a:ln>
         </p:spPr>
+        <p:txBody>
+          <a:bodyPr/>
+          <a:lstStyle/>
+          <a:p>
+            <a:endParaRPr lang="es-ES"/>
+          </a:p>
+        </p:txBody>
       </p:sp>
       <p:sp>
         <p:nvSpPr>
@@ -4258,7 +4054,7 @@
           <a:bodyPr wrap="square" rtlCol="0" anchor="ctr"/>
           <a:lstStyle/>
           <a:p>
-            <a:pPr indent="0" marL="0">
+            <a:pPr marL="0" indent="0">
               <a:buNone/>
             </a:pPr>
             <a:r>
@@ -4297,7 +4093,7 @@
           <a:bodyPr wrap="square" rtlCol="0" anchor="t"/>
           <a:lstStyle/>
           <a:p>
-            <a:pPr indent="0" marL="0">
+            <a:pPr marL="0" indent="0">
               <a:buNone/>
             </a:pPr>
             <a:r>
@@ -4364,6 +4160,13 @@
             <a:prstDash val="solid"/>
           </a:ln>
         </p:spPr>
+        <p:txBody>
+          <a:bodyPr/>
+          <a:lstStyle/>
+          <a:p>
+            <a:endParaRPr lang="es-ES"/>
+          </a:p>
+        </p:txBody>
       </p:sp>
       <p:sp>
         <p:nvSpPr>
@@ -4386,7 +4189,7 @@
           <a:bodyPr wrap="square" rtlCol="0" anchor="ctr"/>
           <a:lstStyle/>
           <a:p>
-            <a:pPr indent="0" marL="0">
+            <a:pPr marL="0" indent="0">
               <a:buNone/>
             </a:pPr>
             <a:r>
@@ -4425,7 +4228,7 @@
           <a:bodyPr wrap="square" rtlCol="0" anchor="ctr"/>
           <a:lstStyle/>
           <a:p>
-            <a:pPr algn="r" indent="0" marL="0">
+            <a:pPr marL="0" indent="0" algn="r">
               <a:buNone/>
             </a:pPr>
             <a:r>
@@ -4467,6 +4270,13 @@
             <a:prstDash val="solid"/>
           </a:ln>
         </p:spPr>
+        <p:txBody>
+          <a:bodyPr/>
+          <a:lstStyle/>
+          <a:p>
+            <a:endParaRPr lang="es-ES"/>
+          </a:p>
+        </p:txBody>
       </p:sp>
       <p:sp>
         <p:nvSpPr>
@@ -4489,7 +4299,7 @@
           <a:bodyPr wrap="square" rtlCol="0" anchor="ctr"/>
           <a:lstStyle/>
           <a:p>
-            <a:pPr indent="0" marL="0">
+            <a:pPr marL="0" indent="0">
               <a:buNone/>
             </a:pPr>
             <a:r>
@@ -4528,7 +4338,7 @@
           <a:bodyPr wrap="square" rtlCol="0" anchor="t"/>
           <a:lstStyle/>
           <a:p>
-            <a:pPr indent="0" marL="0">
+            <a:pPr marL="0" indent="0">
               <a:buNone/>
             </a:pPr>
             <a:r>
@@ -4595,6 +4405,13 @@
             <a:prstDash val="solid"/>
           </a:ln>
         </p:spPr>
+        <p:txBody>
+          <a:bodyPr/>
+          <a:lstStyle/>
+          <a:p>
+            <a:endParaRPr lang="es-ES"/>
+          </a:p>
+        </p:txBody>
       </p:sp>
       <p:sp>
         <p:nvSpPr>
@@ -4617,7 +4434,7 @@
           <a:bodyPr wrap="square" rtlCol="0" anchor="ctr"/>
           <a:lstStyle/>
           <a:p>
-            <a:pPr indent="0" marL="0">
+            <a:pPr marL="0" indent="0">
               <a:buNone/>
             </a:pPr>
             <a:r>
@@ -4656,7 +4473,7 @@
           <a:bodyPr wrap="square" rtlCol="0" anchor="ctr"/>
           <a:lstStyle/>
           <a:p>
-            <a:pPr algn="r" indent="0" marL="0">
+            <a:pPr marL="0" indent="0" algn="r">
               <a:buNone/>
             </a:pPr>
             <a:r>
@@ -4695,7 +4512,7 @@
           <a:bodyPr wrap="square" rtlCol="0" anchor="t"/>
           <a:lstStyle/>
           <a:p>
-            <a:pPr indent="0" marL="0">
+            <a:pPr marL="0" indent="0">
               <a:buNone/>
             </a:pPr>
             <a:r>
@@ -4737,6 +4554,13 @@
             <a:prstDash val="solid"/>
           </a:ln>
         </p:spPr>
+        <p:txBody>
+          <a:bodyPr/>
+          <a:lstStyle/>
+          <a:p>
+            <a:endParaRPr lang="es-ES"/>
+          </a:p>
+        </p:txBody>
       </p:sp>
       <p:sp>
         <p:nvSpPr>
@@ -4759,7 +4583,7 @@
           <a:bodyPr wrap="square" rtlCol="0" anchor="ctr"/>
           <a:lstStyle/>
           <a:p>
-            <a:pPr indent="0" marL="0">
+            <a:pPr marL="0" indent="0">
               <a:buNone/>
             </a:pPr>
             <a:r>
@@ -4826,6 +4650,13 @@
             <a:prstDash val="solid"/>
           </a:ln>
         </p:spPr>
+        <p:txBody>
+          <a:bodyPr/>
+          <a:lstStyle/>
+          <a:p>
+            <a:endParaRPr lang="es-ES"/>
+          </a:p>
+        </p:txBody>
       </p:sp>
       <p:sp>
         <p:nvSpPr>
@@ -4848,7 +4679,7 @@
           <a:bodyPr wrap="square" rtlCol="0" anchor="ctr"/>
           <a:lstStyle/>
           <a:p>
-            <a:pPr indent="0" marL="0">
+            <a:pPr marL="0" indent="0">
               <a:buNone/>
             </a:pPr>
             <a:r>
@@ -4887,7 +4718,7 @@
           <a:bodyPr wrap="square" rtlCol="0" anchor="ctr"/>
           <a:lstStyle/>
           <a:p>
-            <a:pPr algn="r" indent="0" marL="0">
+            <a:pPr marL="0" indent="0" algn="r">
               <a:buNone/>
             </a:pPr>
             <a:r>
@@ -4929,6 +4760,13 @@
             <a:prstDash val="solid"/>
           </a:ln>
         </p:spPr>
+        <p:txBody>
+          <a:bodyPr/>
+          <a:lstStyle/>
+          <a:p>
+            <a:endParaRPr lang="es-ES"/>
+          </a:p>
+        </p:txBody>
       </p:sp>
       <p:sp>
         <p:nvSpPr>
@@ -4954,6 +4792,13 @@
             <a:prstDash val="solid"/>
           </a:ln>
         </p:spPr>
+        <p:txBody>
+          <a:bodyPr/>
+          <a:lstStyle/>
+          <a:p>
+            <a:endParaRPr lang="es-ES"/>
+          </a:p>
+        </p:txBody>
       </p:sp>
       <p:sp>
         <p:nvSpPr>
@@ -4976,7 +4821,7 @@
           <a:bodyPr wrap="square" rtlCol="0" anchor="t"/>
           <a:lstStyle/>
           <a:p>
-            <a:pPr indent="0" marL="0">
+            <a:pPr marL="0" indent="0">
               <a:buNone/>
             </a:pPr>
             <a:r>
@@ -4993,7 +4838,7 @@
             <a:endParaRPr lang="en-US" sz="1700" dirty="0"/>
           </a:p>
           <a:p>
-            <a:pPr indent="0" marL="0">
+            <a:pPr marL="0" indent="0">
               <a:buNone/>
             </a:pPr>
             <a:r>
@@ -5032,7 +4877,7 @@
           <a:bodyPr wrap="square" rtlCol="0" anchor="t"/>
           <a:lstStyle/>
           <a:p>
-            <a:pPr indent="0" marL="0">
+            <a:pPr marL="0" indent="0">
               <a:buNone/>
             </a:pPr>
             <a:r>
@@ -5074,6 +4919,13 @@
             <a:prstDash val="solid"/>
           </a:ln>
         </p:spPr>
+        <p:txBody>
+          <a:bodyPr/>
+          <a:lstStyle/>
+          <a:p>
+            <a:endParaRPr lang="es-ES"/>
+          </a:p>
+        </p:txBody>
       </p:sp>
       <p:sp>
         <p:nvSpPr>
@@ -5099,6 +4951,13 @@
             <a:prstDash val="solid"/>
           </a:ln>
         </p:spPr>
+        <p:txBody>
+          <a:bodyPr/>
+          <a:lstStyle/>
+          <a:p>
+            <a:endParaRPr lang="es-ES"/>
+          </a:p>
+        </p:txBody>
       </p:sp>
       <p:sp>
         <p:nvSpPr>
@@ -5121,7 +4980,7 @@
           <a:bodyPr wrap="square" rtlCol="0" anchor="t"/>
           <a:lstStyle/>
           <a:p>
-            <a:pPr indent="0" marL="0">
+            <a:pPr marL="0" indent="0">
               <a:buNone/>
             </a:pPr>
             <a:r>
@@ -5138,7 +4997,7 @@
             <a:endParaRPr lang="en-US" sz="1700" dirty="0"/>
           </a:p>
           <a:p>
-            <a:pPr indent="0" marL="0">
+            <a:pPr marL="0" indent="0">
               <a:buNone/>
             </a:pPr>
             <a:r>
@@ -5177,7 +5036,7 @@
           <a:bodyPr wrap="square" rtlCol="0" anchor="t"/>
           <a:lstStyle/>
           <a:p>
-            <a:pPr indent="0" marL="0">
+            <a:pPr marL="0" indent="0">
               <a:buNone/>
             </a:pPr>
             <a:r>
@@ -5244,6 +5103,13 @@
             <a:prstDash val="solid"/>
           </a:ln>
         </p:spPr>
+        <p:txBody>
+          <a:bodyPr/>
+          <a:lstStyle/>
+          <a:p>
+            <a:endParaRPr lang="es-ES"/>
+          </a:p>
+        </p:txBody>
       </p:sp>
       <p:sp>
         <p:nvSpPr>
@@ -5266,7 +5132,7 @@
           <a:bodyPr wrap="square" rtlCol="0" anchor="ctr"/>
           <a:lstStyle/>
           <a:p>
-            <a:pPr indent="0" marL="0">
+            <a:pPr marL="0" indent="0">
               <a:buNone/>
             </a:pPr>
             <a:r>
@@ -5305,7 +5171,7 @@
           <a:bodyPr wrap="square" rtlCol="0" anchor="ctr"/>
           <a:lstStyle/>
           <a:p>
-            <a:pPr algn="r" indent="0" marL="0">
+            <a:pPr marL="0" indent="0" algn="r">
               <a:buNone/>
             </a:pPr>
             <a:r>
@@ -5344,7 +5210,7 @@
           <a:bodyPr wrap="square" rtlCol="0" anchor="t"/>
           <a:lstStyle/>
           <a:p>
-            <a:pPr indent="0" marL="0">
+            <a:pPr marL="0" indent="0">
               <a:buNone/>
             </a:pPr>
             <a:r>
@@ -5386,6 +5252,13 @@
             <a:prstDash val="solid"/>
           </a:ln>
         </p:spPr>
+        <p:txBody>
+          <a:bodyPr/>
+          <a:lstStyle/>
+          <a:p>
+            <a:endParaRPr lang="es-ES"/>
+          </a:p>
+        </p:txBody>
       </p:sp>
       <p:sp>
         <p:nvSpPr>
@@ -5408,7 +5281,7 @@
           <a:bodyPr wrap="square" rtlCol="0" anchor="ctr"/>
           <a:lstStyle/>
           <a:p>
-            <a:pPr indent="0" marL="0">
+            <a:pPr marL="0" indent="0">
               <a:buNone/>
             </a:pPr>
             <a:r>
@@ -5475,6 +5348,13 @@
             <a:prstDash val="solid"/>
           </a:ln>
         </p:spPr>
+        <p:txBody>
+          <a:bodyPr/>
+          <a:lstStyle/>
+          <a:p>
+            <a:endParaRPr lang="es-ES"/>
+          </a:p>
+        </p:txBody>
       </p:sp>
       <p:sp>
         <p:nvSpPr>
@@ -5497,7 +5377,7 @@
           <a:bodyPr wrap="square" rtlCol="0" anchor="ctr"/>
           <a:lstStyle/>
           <a:p>
-            <a:pPr indent="0" marL="0">
+            <a:pPr marL="0" indent="0">
               <a:buNone/>
             </a:pPr>
             <a:r>
@@ -5536,7 +5416,7 @@
           <a:bodyPr wrap="square" rtlCol="0" anchor="ctr"/>
           <a:lstStyle/>
           <a:p>
-            <a:pPr algn="r" indent="0" marL="0">
+            <a:pPr marL="0" indent="0" algn="r">
               <a:buNone/>
             </a:pPr>
             <a:r>
@@ -5570,15 +5450,27 @@
         </p:nvGraphicFramePr>
         <p:xfrm>
           <a:off x="548640" y="1463040"/>
-          <a:ext cx="11091672" cy="914400"/>
+          <a:ext cx="11091672" cy="3291840"/>
         </p:xfrm>
         <a:graphic>
           <a:graphicData uri="http://schemas.openxmlformats.org/drawingml/2006/table">
             <a:tbl>
               <a:tblPr/>
               <a:tblGrid>
-                <a:gridCol w="3327502"/>
-                <a:gridCol w="7764170"/>
+                <a:gridCol w="3327502">
+                  <a:extLst>
+                    <a:ext uri="{9D8B030D-6E8A-4147-A177-3AD203B41FA5}">
+                      <a16:colId xmlns:a16="http://schemas.microsoft.com/office/drawing/2014/main" val="20000"/>
+                    </a:ext>
+                  </a:extLst>
+                </a:gridCol>
+                <a:gridCol w="7764170">
+                  <a:extLst>
+                    <a:ext uri="{9D8B030D-6E8A-4147-A177-3AD203B41FA5}">
+                      <a16:colId xmlns:a16="http://schemas.microsoft.com/office/drawing/2014/main" val="20001"/>
+                    </a:ext>
+                  </a:extLst>
+                </a:gridCol>
               </a:tblGrid>
               <a:tr h="822960">
                 <a:tc>
@@ -5586,7 +5478,7 @@
                     <a:bodyPr/>
                     <a:lstStyle/>
                     <a:p>
-                      <a:pPr algn="ctr" indent="0" marL="0">
+                      <a:pPr marL="0" indent="0" algn="ctr">
                         <a:buNone/>
                       </a:pPr>
                       <a:r>
@@ -5607,7 +5499,7 @@
                       </a:endParaRPr>
                     </a:p>
                   </a:txBody>
-                  <a:tcPr marL="91440" marR="91440" marT="45720" marB="45720" anchor="ctr">
+                  <a:tcPr anchor="ctr">
                     <a:lnL w="12700" cap="flat" cmpd="sng" algn="ctr">
                       <a:solidFill>
                         <a:srgbClr val="EEEEEE"/>
@@ -5654,7 +5546,7 @@
                     <a:bodyPr/>
                     <a:lstStyle/>
                     <a:p>
-                      <a:pPr algn="ctr" indent="0" marL="0">
+                      <a:pPr marL="0" indent="0" algn="ctr">
                         <a:buNone/>
                       </a:pPr>
                       <a:r>
@@ -5675,7 +5567,7 @@
                       </a:endParaRPr>
                     </a:p>
                   </a:txBody>
-                  <a:tcPr marL="91440" marR="91440" marT="45720" marB="45720" anchor="ctr">
+                  <a:tcPr anchor="ctr">
                     <a:lnL w="12700" cap="flat" cmpd="sng" algn="ctr">
                       <a:solidFill>
                         <a:srgbClr val="EEEEEE"/>
@@ -5717,6 +5609,11 @@
                     </a:solidFill>
                   </a:tcPr>
                 </a:tc>
+                <a:extLst>
+                  <a:ext uri="{0D108BD9-81ED-4DB2-BD59-A6C34878D82A}">
+                    <a16:rowId xmlns:a16="http://schemas.microsoft.com/office/drawing/2014/main" val="10000"/>
+                  </a:ext>
+                </a:extLst>
               </a:tr>
               <a:tr h="822960">
                 <a:tc>
@@ -5724,7 +5621,7 @@
                     <a:bodyPr/>
                     <a:lstStyle/>
                     <a:p>
-                      <a:pPr indent="0" marL="0">
+                      <a:pPr marL="0" indent="0">
                         <a:buNone/>
                       </a:pPr>
                       <a:r>
@@ -5745,7 +5642,7 @@
                       </a:endParaRPr>
                     </a:p>
                   </a:txBody>
-                  <a:tcPr marL="91440" marR="91440" marT="45720" marB="45720" anchor="ctr">
+                  <a:tcPr anchor="ctr">
                     <a:lnL w="12700" cap="flat" cmpd="sng" algn="ctr">
                       <a:solidFill>
                         <a:srgbClr val="EEEEEE"/>
@@ -5792,7 +5689,7 @@
                     <a:bodyPr/>
                     <a:lstStyle/>
                     <a:p>
-                      <a:pPr indent="0" marL="0">
+                      <a:pPr marL="0" indent="0">
                         <a:buNone/>
                       </a:pPr>
                       <a:r>
@@ -5813,7 +5710,7 @@
                       </a:endParaRPr>
                     </a:p>
                   </a:txBody>
-                  <a:tcPr marL="91440" marR="91440" marT="45720" marB="45720" anchor="ctr">
+                  <a:tcPr anchor="ctr">
                     <a:lnL w="12700" cap="flat" cmpd="sng" algn="ctr">
                       <a:solidFill>
                         <a:srgbClr val="EEEEEE"/>
@@ -5855,6 +5752,11 @@
                     </a:solidFill>
                   </a:tcPr>
                 </a:tc>
+                <a:extLst>
+                  <a:ext uri="{0D108BD9-81ED-4DB2-BD59-A6C34878D82A}">
+                    <a16:rowId xmlns:a16="http://schemas.microsoft.com/office/drawing/2014/main" val="10001"/>
+                  </a:ext>
+                </a:extLst>
               </a:tr>
               <a:tr h="822960">
                 <a:tc>
@@ -5862,7 +5764,7 @@
                     <a:bodyPr/>
                     <a:lstStyle/>
                     <a:p>
-                      <a:pPr indent="0" marL="0">
+                      <a:pPr marL="0" indent="0">
                         <a:buNone/>
                       </a:pPr>
                       <a:r>
@@ -5883,7 +5785,7 @@
                       </a:endParaRPr>
                     </a:p>
                   </a:txBody>
-                  <a:tcPr marL="91440" marR="91440" marT="45720" marB="45720" anchor="ctr">
+                  <a:tcPr anchor="ctr">
                     <a:lnL w="12700" cap="flat" cmpd="sng" algn="ctr">
                       <a:solidFill>
                         <a:srgbClr val="EEEEEE"/>
@@ -5930,7 +5832,7 @@
                     <a:bodyPr/>
                     <a:lstStyle/>
                     <a:p>
-                      <a:pPr indent="0" marL="0">
+                      <a:pPr marL="0" indent="0">
                         <a:buNone/>
                       </a:pPr>
                       <a:r>
@@ -5951,7 +5853,7 @@
                       </a:endParaRPr>
                     </a:p>
                   </a:txBody>
-                  <a:tcPr marL="91440" marR="91440" marT="45720" marB="45720" anchor="ctr">
+                  <a:tcPr anchor="ctr">
                     <a:lnL w="12700" cap="flat" cmpd="sng" algn="ctr">
                       <a:solidFill>
                         <a:srgbClr val="EEEEEE"/>
@@ -5993,6 +5895,11 @@
                     </a:solidFill>
                   </a:tcPr>
                 </a:tc>
+                <a:extLst>
+                  <a:ext uri="{0D108BD9-81ED-4DB2-BD59-A6C34878D82A}">
+                    <a16:rowId xmlns:a16="http://schemas.microsoft.com/office/drawing/2014/main" val="10002"/>
+                  </a:ext>
+                </a:extLst>
               </a:tr>
               <a:tr h="822960">
                 <a:tc>
@@ -6000,7 +5907,7 @@
                     <a:bodyPr/>
                     <a:lstStyle/>
                     <a:p>
-                      <a:pPr indent="0" marL="0">
+                      <a:pPr marL="0" indent="0">
                         <a:buNone/>
                       </a:pPr>
                       <a:r>
@@ -6021,7 +5928,7 @@
                       </a:endParaRPr>
                     </a:p>
                   </a:txBody>
-                  <a:tcPr marL="91440" marR="91440" marT="45720" marB="45720" anchor="ctr">
+                  <a:tcPr anchor="ctr">
                     <a:lnL w="12700" cap="flat" cmpd="sng" algn="ctr">
                       <a:solidFill>
                         <a:srgbClr val="EEEEEE"/>
@@ -6068,7 +5975,7 @@
                     <a:bodyPr/>
                     <a:lstStyle/>
                     <a:p>
-                      <a:pPr indent="0" marL="0">
+                      <a:pPr marL="0" indent="0">
                         <a:buNone/>
                       </a:pPr>
                       <a:r>
@@ -6089,7 +5996,7 @@
                       </a:endParaRPr>
                     </a:p>
                   </a:txBody>
-                  <a:tcPr marL="91440" marR="91440" marT="45720" marB="45720" anchor="ctr">
+                  <a:tcPr anchor="ctr">
                     <a:lnL w="12700" cap="flat" cmpd="sng" algn="ctr">
                       <a:solidFill>
                         <a:srgbClr val="EEEEEE"/>
@@ -6131,6 +6038,11 @@
                     </a:solidFill>
                   </a:tcPr>
                 </a:tc>
+                <a:extLst>
+                  <a:ext uri="{0D108BD9-81ED-4DB2-BD59-A6C34878D82A}">
+                    <a16:rowId xmlns:a16="http://schemas.microsoft.com/office/drawing/2014/main" val="10003"/>
+                  </a:ext>
+                </a:extLst>
               </a:tr>
             </a:tbl>
           </a:graphicData>
@@ -6157,7 +6069,7 @@
           <a:bodyPr wrap="square" rtlCol="0" anchor="t"/>
           <a:lstStyle/>
           <a:p>
-            <a:pPr indent="0" marL="0">
+            <a:pPr marL="0" indent="0">
               <a:buNone/>
             </a:pPr>
             <a:r>
@@ -6224,6 +6136,13 @@
             <a:prstDash val="solid"/>
           </a:ln>
         </p:spPr>
+        <p:txBody>
+          <a:bodyPr/>
+          <a:lstStyle/>
+          <a:p>
+            <a:endParaRPr lang="es-ES"/>
+          </a:p>
+        </p:txBody>
       </p:sp>
       <p:sp>
         <p:nvSpPr>
@@ -6246,7 +6165,7 @@
           <a:bodyPr wrap="square" rtlCol="0" anchor="ctr"/>
           <a:lstStyle/>
           <a:p>
-            <a:pPr indent="0" marL="0">
+            <a:pPr marL="0" indent="0">
               <a:buNone/>
             </a:pPr>
             <a:r>
@@ -6285,7 +6204,7 @@
           <a:bodyPr wrap="square" rtlCol="0" anchor="ctr"/>
           <a:lstStyle/>
           <a:p>
-            <a:pPr algn="r" indent="0" marL="0">
+            <a:pPr marL="0" indent="0" algn="r">
               <a:buNone/>
             </a:pPr>
             <a:r>
@@ -6455,6 +6374,13 @@
             <a:prstDash val="solid"/>
           </a:ln>
         </p:spPr>
+        <p:txBody>
+          <a:bodyPr/>
+          <a:lstStyle/>
+          <a:p>
+            <a:endParaRPr lang="es-ES"/>
+          </a:p>
+        </p:txBody>
       </p:sp>
       <p:sp>
         <p:nvSpPr>
@@ -6477,7 +6403,7 @@
           <a:bodyPr wrap="square" rtlCol="0" anchor="ctr"/>
           <a:lstStyle/>
           <a:p>
-            <a:pPr indent="0" marL="0">
+            <a:pPr marL="0" indent="0">
               <a:buNone/>
             </a:pPr>
             <a:r>
@@ -6516,7 +6442,7 @@
           <a:bodyPr wrap="square" rtlCol="0" anchor="ctr"/>
           <a:lstStyle/>
           <a:p>
-            <a:pPr algn="r" indent="0" marL="0">
+            <a:pPr marL="0" indent="0" algn="r">
               <a:buNone/>
             </a:pPr>
             <a:r>
@@ -6686,6 +6612,13 @@
             <a:prstDash val="solid"/>
           </a:ln>
         </p:spPr>
+        <p:txBody>
+          <a:bodyPr/>
+          <a:lstStyle/>
+          <a:p>
+            <a:endParaRPr lang="es-ES"/>
+          </a:p>
+        </p:txBody>
       </p:sp>
       <p:sp>
         <p:nvSpPr>
@@ -6708,7 +6641,7 @@
           <a:bodyPr wrap="square" rtlCol="0" anchor="ctr"/>
           <a:lstStyle/>
           <a:p>
-            <a:pPr indent="0" marL="0">
+            <a:pPr marL="0" indent="0">
               <a:buNone/>
             </a:pPr>
             <a:r>
@@ -6747,7 +6680,7 @@
           <a:bodyPr wrap="square" rtlCol="0" anchor="ctr"/>
           <a:lstStyle/>
           <a:p>
-            <a:pPr algn="r" indent="0" marL="0">
+            <a:pPr marL="0" indent="0" algn="r">
               <a:buNone/>
             </a:pPr>
             <a:r>
@@ -6789,6 +6722,13 @@
             <a:prstDash val="solid"/>
           </a:ln>
         </p:spPr>
+        <p:txBody>
+          <a:bodyPr/>
+          <a:lstStyle/>
+          <a:p>
+            <a:endParaRPr lang="es-ES"/>
+          </a:p>
+        </p:txBody>
       </p:sp>
       <p:sp>
         <p:nvSpPr>
@@ -6811,7 +6751,7 @@
           <a:bodyPr wrap="square" rtlCol="0" anchor="ctr"/>
           <a:lstStyle/>
           <a:p>
-            <a:pPr indent="0" marL="0">
+            <a:pPr marL="0" indent="0">
               <a:buNone/>
             </a:pPr>
             <a:r>
@@ -6850,7 +6790,7 @@
           <a:bodyPr wrap="square" rtlCol="0" anchor="t"/>
           <a:lstStyle/>
           <a:p>
-            <a:pPr indent="0" marL="0">
+            <a:pPr marL="0" indent="0">
               <a:buNone/>
             </a:pPr>
             <a:r>
@@ -6917,6 +6857,13 @@
             <a:prstDash val="solid"/>
           </a:ln>
         </p:spPr>
+        <p:txBody>
+          <a:bodyPr/>
+          <a:lstStyle/>
+          <a:p>
+            <a:endParaRPr lang="es-ES"/>
+          </a:p>
+        </p:txBody>
       </p:sp>
       <p:sp>
         <p:nvSpPr>
@@ -6939,7 +6886,7 @@
           <a:bodyPr wrap="square" rtlCol="0" anchor="ctr"/>
           <a:lstStyle/>
           <a:p>
-            <a:pPr indent="0" marL="0">
+            <a:pPr marL="0" indent="0">
               <a:buNone/>
             </a:pPr>
             <a:r>
@@ -6978,7 +6925,7 @@
           <a:bodyPr wrap="square" rtlCol="0" anchor="ctr"/>
           <a:lstStyle/>
           <a:p>
-            <a:pPr algn="r" indent="0" marL="0">
+            <a:pPr marL="0" indent="0" algn="r">
               <a:buNone/>
             </a:pPr>
             <a:r>
@@ -7017,7 +6964,7 @@
           <a:bodyPr wrap="square" rtlCol="0" anchor="t"/>
           <a:lstStyle/>
           <a:p>
-            <a:pPr indent="0" marL="0">
+            <a:pPr marL="0" indent="0">
               <a:buNone/>
             </a:pPr>
             <a:r>
@@ -7043,8 +6990,8 @@
         </p:nvSpPr>
         <p:spPr>
           <a:xfrm>
-            <a:off x="548640" y="2514600"/>
-            <a:ext cx="11091672" cy="2011680"/>
+            <a:off x="548640" y="2514599"/>
+            <a:ext cx="11091672" cy="2505269"/>
           </a:xfrm>
           <a:prstGeom prst="rect">
             <a:avLst/>
@@ -7059,6 +7006,13 @@
             <a:prstDash val="solid"/>
           </a:ln>
         </p:spPr>
+        <p:txBody>
+          <a:bodyPr/>
+          <a:lstStyle/>
+          <a:p>
+            <a:endParaRPr lang="es-ES"/>
+          </a:p>
+        </p:txBody>
       </p:sp>
       <p:sp>
         <p:nvSpPr>
@@ -7069,7 +7023,7 @@
         <p:spPr>
           <a:xfrm>
             <a:off x="548640" y="2514600"/>
-            <a:ext cx="73152" cy="2011680"/>
+            <a:ext cx="73152" cy="2505268"/>
           </a:xfrm>
           <a:prstGeom prst="rect">
             <a:avLst/>
@@ -7084,6 +7038,13 @@
             <a:prstDash val="solid"/>
           </a:ln>
         </p:spPr>
+        <p:txBody>
+          <a:bodyPr/>
+          <a:lstStyle/>
+          <a:p>
+            <a:endParaRPr lang="es-ES"/>
+          </a:p>
+        </p:txBody>
       </p:sp>
       <p:sp>
         <p:nvSpPr>
@@ -7106,7 +7067,7 @@
           <a:bodyPr wrap="square" rtlCol="0" anchor="t"/>
           <a:lstStyle/>
           <a:p>
-            <a:pPr indent="0" marL="0">
+            <a:pPr marL="0" indent="0">
               <a:buNone/>
             </a:pPr>
             <a:r>
@@ -7123,7 +7084,7 @@
             <a:endParaRPr lang="en-US" sz="1500" dirty="0"/>
           </a:p>
           <a:p>
-            <a:pPr indent="0" marL="0">
+            <a:pPr marL="0" indent="0">
               <a:buNone/>
             </a:pPr>
             <a:r>
@@ -7140,7 +7101,7 @@
             <a:endParaRPr lang="en-US" sz="1500" dirty="0"/>
           </a:p>
           <a:p>
-            <a:pPr indent="0" marL="0">
+            <a:pPr marL="0" indent="0">
               <a:buNone/>
             </a:pPr>
             <a:r>
@@ -7157,7 +7118,7 @@
             <a:endParaRPr lang="en-US" sz="1500" dirty="0"/>
           </a:p>
           <a:p>
-            <a:pPr indent="0" marL="0">
+            <a:pPr marL="0" indent="0">
               <a:buNone/>
             </a:pPr>
             <a:r>
@@ -7174,7 +7135,7 @@
             <a:endParaRPr lang="en-US" sz="1500" dirty="0"/>
           </a:p>
           <a:p>
-            <a:pPr indent="0" marL="0">
+            <a:pPr marL="0" indent="0">
               <a:buNone/>
             </a:pPr>
             <a:r>
@@ -7191,7 +7152,7 @@
             <a:endParaRPr lang="en-US" sz="1500" dirty="0"/>
           </a:p>
           <a:p>
-            <a:pPr indent="0" marL="0">
+            <a:pPr marL="0" indent="0">
               <a:buNone/>
             </a:pPr>
             <a:r>
@@ -7208,7 +7169,7 @@
             <a:endParaRPr lang="en-US" sz="1500" dirty="0"/>
           </a:p>
           <a:p>
-            <a:pPr indent="0" marL="0">
+            <a:pPr marL="0" indent="0">
               <a:buNone/>
             </a:pPr>
             <a:r>
@@ -7225,7 +7186,7 @@
             <a:endParaRPr lang="en-US" sz="1500" dirty="0"/>
           </a:p>
           <a:p>
-            <a:pPr indent="0" marL="0">
+            <a:pPr marL="0" indent="0">
               <a:buNone/>
             </a:pPr>
             <a:r>
@@ -7242,7 +7203,7 @@
             <a:endParaRPr lang="en-US" sz="1500" dirty="0"/>
           </a:p>
           <a:p>
-            <a:pPr indent="0" marL="0">
+            <a:pPr marL="0" indent="0">
               <a:buNone/>
             </a:pPr>
             <a:r>
@@ -7268,7 +7229,7 @@
         </p:nvSpPr>
         <p:spPr>
           <a:xfrm>
-            <a:off x="548640" y="4800600"/>
+            <a:off x="571500" y="5180076"/>
             <a:ext cx="11091672" cy="640080"/>
           </a:xfrm>
           <a:prstGeom prst="rect">
@@ -7281,7 +7242,7 @@
           <a:bodyPr wrap="square" rtlCol="0" anchor="t"/>
           <a:lstStyle/>
           <a:p>
-            <a:pPr indent="0" marL="0">
+            <a:pPr marL="0" indent="0">
               <a:buNone/>
             </a:pPr>
             <a:r>
@@ -7348,6 +7309,13 @@
             <a:prstDash val="solid"/>
           </a:ln>
         </p:spPr>
+        <p:txBody>
+          <a:bodyPr/>
+          <a:lstStyle/>
+          <a:p>
+            <a:endParaRPr lang="es-ES"/>
+          </a:p>
+        </p:txBody>
       </p:sp>
       <p:sp>
         <p:nvSpPr>
@@ -7370,7 +7338,7 @@
           <a:bodyPr wrap="square" rtlCol="0" anchor="ctr"/>
           <a:lstStyle/>
           <a:p>
-            <a:pPr indent="0" marL="0">
+            <a:pPr marL="0" indent="0">
               <a:buNone/>
             </a:pPr>
             <a:r>
@@ -7409,7 +7377,7 @@
           <a:bodyPr wrap="square" rtlCol="0" anchor="ctr"/>
           <a:lstStyle/>
           <a:p>
-            <a:pPr algn="r" indent="0" marL="0">
+            <a:pPr marL="0" indent="0" algn="r">
               <a:buNone/>
             </a:pPr>
             <a:r>
@@ -7537,6 +7505,13 @@
             <a:prstDash val="solid"/>
           </a:ln>
         </p:spPr>
+        <p:txBody>
+          <a:bodyPr/>
+          <a:lstStyle/>
+          <a:p>
+            <a:endParaRPr lang="es-ES"/>
+          </a:p>
+        </p:txBody>
       </p:sp>
       <p:sp>
         <p:nvSpPr>
@@ -7559,7 +7534,7 @@
           <a:bodyPr wrap="square" rtlCol="0" anchor="ctr"/>
           <a:lstStyle/>
           <a:p>
-            <a:pPr indent="0" marL="0">
+            <a:pPr marL="0" indent="0">
               <a:buNone/>
             </a:pPr>
             <a:r>
@@ -7598,7 +7573,7 @@
           <a:bodyPr wrap="square" rtlCol="0" anchor="ctr"/>
           <a:lstStyle/>
           <a:p>
-            <a:pPr algn="r" indent="0" marL="0">
+            <a:pPr marL="0" indent="0" algn="r">
               <a:buNone/>
             </a:pPr>
             <a:r>
@@ -7640,6 +7615,13 @@
             <a:prstDash val="solid"/>
           </a:ln>
         </p:spPr>
+        <p:txBody>
+          <a:bodyPr/>
+          <a:lstStyle/>
+          <a:p>
+            <a:endParaRPr lang="es-ES"/>
+          </a:p>
+        </p:txBody>
       </p:sp>
       <p:sp>
         <p:nvSpPr>
@@ -7662,7 +7644,7 @@
           <a:bodyPr wrap="square" rtlCol="0" anchor="ctr"/>
           <a:lstStyle/>
           <a:p>
-            <a:pPr indent="0" marL="0">
+            <a:pPr marL="0" indent="0">
               <a:buNone/>
             </a:pPr>
             <a:r>
@@ -7701,7 +7683,7 @@
           <a:bodyPr wrap="square" rtlCol="0" anchor="t"/>
           <a:lstStyle/>
           <a:p>
-            <a:pPr indent="0" marL="0">
+            <a:pPr marL="0" indent="0">
               <a:buNone/>
             </a:pPr>
             <a:r>
@@ -7768,6 +7750,13 @@
             <a:prstDash val="solid"/>
           </a:ln>
         </p:spPr>
+        <p:txBody>
+          <a:bodyPr/>
+          <a:lstStyle/>
+          <a:p>
+            <a:endParaRPr lang="es-ES"/>
+          </a:p>
+        </p:txBody>
       </p:sp>
       <p:sp>
         <p:nvSpPr>
@@ -7790,7 +7779,7 @@
           <a:bodyPr wrap="square" rtlCol="0" anchor="ctr"/>
           <a:lstStyle/>
           <a:p>
-            <a:pPr indent="0" marL="0">
+            <a:pPr marL="0" indent="0">
               <a:buNone/>
             </a:pPr>
             <a:r>
@@ -7829,7 +7818,7 @@
           <a:bodyPr wrap="square" rtlCol="0" anchor="ctr"/>
           <a:lstStyle/>
           <a:p>
-            <a:pPr algn="r" indent="0" marL="0">
+            <a:pPr marL="0" indent="0" algn="r">
               <a:buNone/>
             </a:pPr>
             <a:r>
@@ -7871,6 +7860,13 @@
             <a:prstDash val="solid"/>
           </a:ln>
         </p:spPr>
+        <p:txBody>
+          <a:bodyPr/>
+          <a:lstStyle/>
+          <a:p>
+            <a:endParaRPr lang="es-ES"/>
+          </a:p>
+        </p:txBody>
       </p:sp>
       <p:sp>
         <p:nvSpPr>
@@ -7893,7 +7889,7 @@
           <a:bodyPr wrap="square" rtlCol="0" anchor="ctr"/>
           <a:lstStyle/>
           <a:p>
-            <a:pPr indent="0" marL="0">
+            <a:pPr marL="0" indent="0">
               <a:buNone/>
             </a:pPr>
             <a:r>
@@ -7960,6 +7956,13 @@
             <a:prstDash val="solid"/>
           </a:ln>
         </p:spPr>
+        <p:txBody>
+          <a:bodyPr/>
+          <a:lstStyle/>
+          <a:p>
+            <a:endParaRPr lang="es-ES"/>
+          </a:p>
+        </p:txBody>
       </p:sp>
       <p:sp>
         <p:nvSpPr>
@@ -7982,7 +7985,7 @@
           <a:bodyPr wrap="square" rtlCol="0" anchor="ctr"/>
           <a:lstStyle/>
           <a:p>
-            <a:pPr indent="0" marL="0">
+            <a:pPr marL="0" indent="0">
               <a:buNone/>
             </a:pPr>
             <a:r>
@@ -8021,7 +8024,7 @@
           <a:bodyPr wrap="square" rtlCol="0" anchor="ctr"/>
           <a:lstStyle/>
           <a:p>
-            <a:pPr algn="r" indent="0" marL="0">
+            <a:pPr marL="0" indent="0" algn="r">
               <a:buNone/>
             </a:pPr>
             <a:r>
@@ -8060,7 +8063,7 @@
           <a:bodyPr wrap="square" rtlCol="0" anchor="t"/>
           <a:lstStyle/>
           <a:p>
-            <a:pPr indent="0" marL="0">
+            <a:pPr marL="0" indent="0">
               <a:buNone/>
             </a:pPr>
             <a:r>
@@ -8102,6 +8105,13 @@
             <a:prstDash val="solid"/>
           </a:ln>
         </p:spPr>
+        <p:txBody>
+          <a:bodyPr/>
+          <a:lstStyle/>
+          <a:p>
+            <a:endParaRPr lang="es-ES"/>
+          </a:p>
+        </p:txBody>
       </p:sp>
       <p:sp>
         <p:nvSpPr>
@@ -8127,6 +8137,13 @@
             <a:prstDash val="solid"/>
           </a:ln>
         </p:spPr>
+        <p:txBody>
+          <a:bodyPr/>
+          <a:lstStyle/>
+          <a:p>
+            <a:endParaRPr lang="es-ES"/>
+          </a:p>
+        </p:txBody>
       </p:sp>
       <p:sp>
         <p:nvSpPr>
@@ -8149,7 +8166,7 @@
           <a:bodyPr wrap="square" rtlCol="0" anchor="t"/>
           <a:lstStyle/>
           <a:p>
-            <a:pPr indent="0" marL="0">
+            <a:pPr marL="0" indent="0">
               <a:buNone/>
             </a:pPr>
             <a:r>
@@ -8166,7 +8183,7 @@
             <a:endParaRPr lang="en-US" sz="1450" dirty="0"/>
           </a:p>
           <a:p>
-            <a:pPr indent="0" marL="0">
+            <a:pPr marL="0" indent="0">
               <a:buNone/>
             </a:pPr>
             <a:r>
@@ -8183,7 +8200,7 @@
             <a:endParaRPr lang="en-US" sz="1450" dirty="0"/>
           </a:p>
           <a:p>
-            <a:pPr indent="0" marL="0">
+            <a:pPr marL="0" indent="0">
               <a:buNone/>
             </a:pPr>
             <a:r>
@@ -8200,13 +8217,13 @@
             <a:endParaRPr lang="en-US" sz="1450" dirty="0"/>
           </a:p>
           <a:p>
-            <a:pPr indent="0" marL="0">
+            <a:pPr marL="0" indent="0">
               <a:buNone/>
             </a:pPr>
             <a:endParaRPr lang="en-US" sz="1450" dirty="0"/>
           </a:p>
           <a:p>
-            <a:pPr indent="0" marL="0">
+            <a:pPr marL="0" indent="0">
               <a:buNone/>
             </a:pPr>
             <a:r>
@@ -8223,13 +8240,13 @@
             <a:endParaRPr lang="en-US" sz="1450" dirty="0"/>
           </a:p>
           <a:p>
-            <a:pPr indent="0" marL="0">
+            <a:pPr marL="0" indent="0">
               <a:buNone/>
             </a:pPr>
             <a:endParaRPr lang="en-US" sz="1450" dirty="0"/>
           </a:p>
           <a:p>
-            <a:pPr indent="0" marL="0">
+            <a:pPr marL="0" indent="0">
               <a:buNone/>
             </a:pPr>
             <a:r>
@@ -8246,7 +8263,7 @@
             <a:endParaRPr lang="en-US" sz="1450" dirty="0"/>
           </a:p>
           <a:p>
-            <a:pPr indent="0" marL="0">
+            <a:pPr marL="0" indent="0">
               <a:buNone/>
             </a:pPr>
             <a:r>
@@ -8263,7 +8280,7 @@
             <a:endParaRPr lang="en-US" sz="1450" dirty="0"/>
           </a:p>
           <a:p>
-            <a:pPr indent="0" marL="0">
+            <a:pPr marL="0" indent="0">
               <a:buNone/>
             </a:pPr>
             <a:r>
@@ -8280,7 +8297,7 @@
             <a:endParaRPr lang="en-US" sz="1450" dirty="0"/>
           </a:p>
           <a:p>
-            <a:pPr indent="0" marL="0">
+            <a:pPr marL="0" indent="0">
               <a:buNone/>
             </a:pPr>
             <a:r>
@@ -8347,6 +8364,13 @@
             <a:prstDash val="solid"/>
           </a:ln>
         </p:spPr>
+        <p:txBody>
+          <a:bodyPr/>
+          <a:lstStyle/>
+          <a:p>
+            <a:endParaRPr lang="es-ES"/>
+          </a:p>
+        </p:txBody>
       </p:sp>
       <p:sp>
         <p:nvSpPr>
@@ -8369,7 +8393,7 @@
           <a:bodyPr wrap="square" rtlCol="0" anchor="ctr"/>
           <a:lstStyle/>
           <a:p>
-            <a:pPr indent="0" marL="0">
+            <a:pPr marL="0" indent="0">
               <a:buNone/>
             </a:pPr>
             <a:r>
@@ -8408,7 +8432,7 @@
           <a:bodyPr wrap="square" rtlCol="0" anchor="ctr"/>
           <a:lstStyle/>
           <a:p>
-            <a:pPr algn="r" indent="0" marL="0">
+            <a:pPr marL="0" indent="0" algn="r">
               <a:buNone/>
             </a:pPr>
             <a:r>
@@ -8450,6 +8474,13 @@
             <a:prstDash val="solid"/>
           </a:ln>
         </p:spPr>
+        <p:txBody>
+          <a:bodyPr/>
+          <a:lstStyle/>
+          <a:p>
+            <a:endParaRPr lang="es-ES"/>
+          </a:p>
+        </p:txBody>
       </p:sp>
       <p:sp>
         <p:nvSpPr>
@@ -8472,7 +8503,7 @@
           <a:bodyPr wrap="square" rtlCol="0" anchor="ctr"/>
           <a:lstStyle/>
           <a:p>
-            <a:pPr indent="0" marL="0">
+            <a:pPr marL="0" indent="0">
               <a:buNone/>
             </a:pPr>
             <a:r>
@@ -8511,7 +8542,7 @@
           <a:bodyPr wrap="square" rtlCol="0" anchor="t"/>
           <a:lstStyle/>
           <a:p>
-            <a:pPr indent="0" marL="0">
+            <a:pPr marL="0" indent="0">
               <a:buNone/>
             </a:pPr>
             <a:r>
@@ -8578,6 +8609,13 @@
             <a:prstDash val="solid"/>
           </a:ln>
         </p:spPr>
+        <p:txBody>
+          <a:bodyPr/>
+          <a:lstStyle/>
+          <a:p>
+            <a:endParaRPr lang="es-ES"/>
+          </a:p>
+        </p:txBody>
       </p:sp>
       <p:sp>
         <p:nvSpPr>
@@ -8600,7 +8638,7 @@
           <a:bodyPr wrap="square" rtlCol="0" anchor="ctr"/>
           <a:lstStyle/>
           <a:p>
-            <a:pPr indent="0" marL="0">
+            <a:pPr marL="0" indent="0">
               <a:buNone/>
             </a:pPr>
             <a:r>
@@ -8639,7 +8677,7 @@
           <a:bodyPr wrap="square" rtlCol="0" anchor="ctr"/>
           <a:lstStyle/>
           <a:p>
-            <a:pPr algn="r" indent="0" marL="0">
+            <a:pPr marL="0" indent="0" algn="r">
               <a:buNone/>
             </a:pPr>
             <a:r>
@@ -8678,7 +8716,7 @@
           <a:bodyPr wrap="square" rtlCol="0" anchor="t"/>
           <a:lstStyle/>
           <a:p>
-            <a:pPr indent="0" marL="0">
+            <a:pPr marL="0" indent="0">
               <a:buNone/>
             </a:pPr>
             <a:r>
@@ -8720,6 +8758,13 @@
             <a:prstDash val="solid"/>
           </a:ln>
         </p:spPr>
+        <p:txBody>
+          <a:bodyPr/>
+          <a:lstStyle/>
+          <a:p>
+            <a:endParaRPr lang="es-ES"/>
+          </a:p>
+        </p:txBody>
       </p:sp>
       <p:sp>
         <p:nvSpPr>
@@ -8745,6 +8790,13 @@
             <a:prstDash val="solid"/>
           </a:ln>
         </p:spPr>
+        <p:txBody>
+          <a:bodyPr/>
+          <a:lstStyle/>
+          <a:p>
+            <a:endParaRPr lang="es-ES"/>
+          </a:p>
+        </p:txBody>
       </p:sp>
       <p:sp>
         <p:nvSpPr>
@@ -8767,7 +8819,7 @@
           <a:bodyPr wrap="square" rtlCol="0" anchor="t"/>
           <a:lstStyle/>
           <a:p>
-            <a:pPr indent="0" marL="0">
+            <a:pPr marL="0" indent="0">
               <a:buNone/>
             </a:pPr>
             <a:r>
@@ -8784,7 +8836,7 @@
             <a:endParaRPr lang="en-US" sz="1500" dirty="0"/>
           </a:p>
           <a:p>
-            <a:pPr indent="0" marL="0">
+            <a:pPr marL="0" indent="0">
               <a:buNone/>
             </a:pPr>
             <a:r>
@@ -8801,7 +8853,7 @@
             <a:endParaRPr lang="en-US" sz="1500" dirty="0"/>
           </a:p>
           <a:p>
-            <a:pPr indent="0" marL="0">
+            <a:pPr marL="0" indent="0">
               <a:buNone/>
             </a:pPr>
             <a:r>
@@ -8818,7 +8870,7 @@
             <a:endParaRPr lang="en-US" sz="1500" dirty="0"/>
           </a:p>
           <a:p>
-            <a:pPr indent="0" marL="0">
+            <a:pPr marL="0" indent="0">
               <a:buNone/>
             </a:pPr>
             <a:r>
@@ -9137,4 +9189,319 @@
     </a:ext>
   </a:extLst>
 </a:theme>
+</file>
+
+<file path=ppt/theme/theme2.xml><?xml version="1.0" encoding="utf-8"?>
+<a:theme xmlns:a="http://schemas.openxmlformats.org/drawingml/2006/main" name="Tema de Office">
+  <a:themeElements>
+    <a:clrScheme name="Office">
+      <a:dk1>
+        <a:sysClr val="windowText" lastClr="000000"/>
+      </a:dk1>
+      <a:lt1>
+        <a:sysClr val="window" lastClr="FFFFFF"/>
+      </a:lt1>
+      <a:dk2>
+        <a:srgbClr val="0E2841"/>
+      </a:dk2>
+      <a:lt2>
+        <a:srgbClr val="E8E8E8"/>
+      </a:lt2>
+      <a:accent1>
+        <a:srgbClr val="156082"/>
+      </a:accent1>
+      <a:accent2>
+        <a:srgbClr val="E97132"/>
+      </a:accent2>
+      <a:accent3>
+        <a:srgbClr val="196B24"/>
+      </a:accent3>
+      <a:accent4>
+        <a:srgbClr val="0F9ED5"/>
+      </a:accent4>
+      <a:accent5>
+        <a:srgbClr val="A02B93"/>
+      </a:accent5>
+      <a:accent6>
+        <a:srgbClr val="4EA72E"/>
+      </a:accent6>
+      <a:hlink>
+        <a:srgbClr val="467886"/>
+      </a:hlink>
+      <a:folHlink>
+        <a:srgbClr val="96607D"/>
+      </a:folHlink>
+    </a:clrScheme>
+    <a:fontScheme name="Office">
+      <a:majorFont>
+        <a:latin typeface="Aptos Display" panose="02110004020202020204"/>
+        <a:ea typeface=""/>
+        <a:cs typeface=""/>
+        <a:font script="Jpan" typeface="游ゴシック Light"/>
+        <a:font script="Hang" typeface="맑은 고딕"/>
+        <a:font script="Hans" typeface="等线 Light"/>
+        <a:font script="Hant" typeface="新細明體"/>
+        <a:font script="Arab" typeface="Times New Roman"/>
+        <a:font script="Hebr" typeface="Times New Roman"/>
+        <a:font script="Thai" typeface="Angsana New"/>
+        <a:font script="Ethi" typeface="Nyala"/>
+        <a:font script="Beng" typeface="Vrinda"/>
+        <a:font script="Gujr" typeface="Shruti"/>
+        <a:font script="Khmr" typeface="MoolBoran"/>
+        <a:font script="Knda" typeface="Tunga"/>
+        <a:font script="Guru" typeface="Raavi"/>
+        <a:font script="Cans" typeface="Euphemia"/>
+        <a:font script="Cher" typeface="Plantagenet Cherokee"/>
+        <a:font script="Yiii" typeface="Microsoft Yi Baiti"/>
+        <a:font script="Tibt" typeface="Microsoft Himalaya"/>
+        <a:font script="Thaa" typeface="MV Boli"/>
+        <a:font script="Deva" typeface="Mangal"/>
+        <a:font script="Telu" typeface="Gautami"/>
+        <a:font script="Taml" typeface="Latha"/>
+        <a:font script="Syrc" typeface="Estrangelo Edessa"/>
+        <a:font script="Orya" typeface="Kalinga"/>
+        <a:font script="Mlym" typeface="Kartika"/>
+        <a:font script="Laoo" typeface="DokChampa"/>
+        <a:font script="Sinh" typeface="Iskoola Pota"/>
+        <a:font script="Mong" typeface="Mongolian Baiti"/>
+        <a:font script="Viet" typeface="Times New Roman"/>
+        <a:font script="Uigh" typeface="Microsoft Uighur"/>
+        <a:font script="Geor" typeface="Sylfaen"/>
+        <a:font script="Armn" typeface="Arial"/>
+        <a:font script="Bugi" typeface="Leelawadee UI"/>
+        <a:font script="Bopo" typeface="Microsoft JhengHei"/>
+        <a:font script="Java" typeface="Javanese Text"/>
+        <a:font script="Lisu" typeface="Segoe UI"/>
+        <a:font script="Mymr" typeface="Myanmar Text"/>
+        <a:font script="Nkoo" typeface="Ebrima"/>
+        <a:font script="Olck" typeface="Nirmala UI"/>
+        <a:font script="Osma" typeface="Ebrima"/>
+        <a:font script="Phag" typeface="Phagspa"/>
+        <a:font script="Syrn" typeface="Estrangelo Edessa"/>
+        <a:font script="Syrj" typeface="Estrangelo Edessa"/>
+        <a:font script="Syre" typeface="Estrangelo Edessa"/>
+        <a:font script="Sora" typeface="Nirmala UI"/>
+        <a:font script="Tale" typeface="Microsoft Tai Le"/>
+        <a:font script="Talu" typeface="Microsoft New Tai Lue"/>
+        <a:font script="Tfng" typeface="Ebrima"/>
+      </a:majorFont>
+      <a:minorFont>
+        <a:latin typeface="Aptos" panose="02110004020202020204"/>
+        <a:ea typeface=""/>
+        <a:cs typeface=""/>
+        <a:font script="Jpan" typeface="游ゴシック"/>
+        <a:font script="Hang" typeface="맑은 고딕"/>
+        <a:font script="Hans" typeface="等线"/>
+        <a:font script="Hant" typeface="新細明體"/>
+        <a:font script="Arab" typeface="Arial"/>
+        <a:font script="Hebr" typeface="Arial"/>
+        <a:font script="Thai" typeface="Cordia New"/>
+        <a:font script="Ethi" typeface="Nyala"/>
+        <a:font script="Beng" typeface="Vrinda"/>
+        <a:font script="Gujr" typeface="Shruti"/>
+        <a:font script="Khmr" typeface="DaunPenh"/>
+        <a:font script="Knda" typeface="Tunga"/>
+        <a:font script="Guru" typeface="Raavi"/>
+        <a:font script="Cans" typeface="Euphemia"/>
+        <a:font script="Cher" typeface="Plantagenet Cherokee"/>
+        <a:font script="Yiii" typeface="Microsoft Yi Baiti"/>
+        <a:font script="Tibt" typeface="Microsoft Himalaya"/>
+        <a:font script="Thaa" typeface="MV Boli"/>
+        <a:font script="Deva" typeface="Mangal"/>
+        <a:font script="Telu" typeface="Gautami"/>
+        <a:font script="Taml" typeface="Latha"/>
+        <a:font script="Syrc" typeface="Estrangelo Edessa"/>
+        <a:font script="Orya" typeface="Kalinga"/>
+        <a:font script="Mlym" typeface="Kartika"/>
+        <a:font script="Laoo" typeface="DokChampa"/>
+        <a:font script="Sinh" typeface="Iskoola Pota"/>
+        <a:font script="Mong" typeface="Mongolian Baiti"/>
+        <a:font script="Viet" typeface="Arial"/>
+        <a:font script="Uigh" typeface="Microsoft Uighur"/>
+        <a:font script="Geor" typeface="Sylfaen"/>
+        <a:font script="Armn" typeface="Arial"/>
+        <a:font script="Bugi" typeface="Leelawadee UI"/>
+        <a:font script="Bopo" typeface="Microsoft JhengHei"/>
+        <a:font script="Java" typeface="Javanese Text"/>
+        <a:font script="Lisu" typeface="Segoe UI"/>
+        <a:font script="Mymr" typeface="Myanmar Text"/>
+        <a:font script="Nkoo" typeface="Ebrima"/>
+        <a:font script="Olck" typeface="Nirmala UI"/>
+        <a:font script="Osma" typeface="Ebrima"/>
+        <a:font script="Phag" typeface="Phagspa"/>
+        <a:font script="Syrn" typeface="Estrangelo Edessa"/>
+        <a:font script="Syrj" typeface="Estrangelo Edessa"/>
+        <a:font script="Syre" typeface="Estrangelo Edessa"/>
+        <a:font script="Sora" typeface="Nirmala UI"/>
+        <a:font script="Tale" typeface="Microsoft Tai Le"/>
+        <a:font script="Talu" typeface="Microsoft New Tai Lue"/>
+        <a:font script="Tfng" typeface="Ebrima"/>
+      </a:minorFont>
+    </a:fontScheme>
+    <a:fmtScheme name="Office">
+      <a:fillStyleLst>
+        <a:solidFill>
+          <a:schemeClr val="phClr"/>
+        </a:solidFill>
+        <a:gradFill rotWithShape="1">
+          <a:gsLst>
+            <a:gs pos="0">
+              <a:schemeClr val="phClr">
+                <a:lumMod val="110000"/>
+                <a:satMod val="105000"/>
+                <a:tint val="67000"/>
+              </a:schemeClr>
+            </a:gs>
+            <a:gs pos="50000">
+              <a:schemeClr val="phClr">
+                <a:lumMod val="105000"/>
+                <a:satMod val="103000"/>
+                <a:tint val="73000"/>
+              </a:schemeClr>
+            </a:gs>
+            <a:gs pos="100000">
+              <a:schemeClr val="phClr">
+                <a:lumMod val="105000"/>
+                <a:satMod val="109000"/>
+                <a:tint val="81000"/>
+              </a:schemeClr>
+            </a:gs>
+          </a:gsLst>
+          <a:lin ang="5400000" scaled="0"/>
+        </a:gradFill>
+        <a:gradFill rotWithShape="1">
+          <a:gsLst>
+            <a:gs pos="0">
+              <a:schemeClr val="phClr">
+                <a:satMod val="103000"/>
+                <a:lumMod val="102000"/>
+                <a:tint val="94000"/>
+              </a:schemeClr>
+            </a:gs>
+            <a:gs pos="50000">
+              <a:schemeClr val="phClr">
+                <a:satMod val="110000"/>
+                <a:lumMod val="100000"/>
+                <a:shade val="100000"/>
+              </a:schemeClr>
+            </a:gs>
+            <a:gs pos="100000">
+              <a:schemeClr val="phClr">
+                <a:lumMod val="99000"/>
+                <a:satMod val="120000"/>
+                <a:shade val="78000"/>
+              </a:schemeClr>
+            </a:gs>
+          </a:gsLst>
+          <a:lin ang="5400000" scaled="0"/>
+        </a:gradFill>
+      </a:fillStyleLst>
+      <a:lnStyleLst>
+        <a:ln w="12700" cap="flat" cmpd="sng" algn="ctr">
+          <a:solidFill>
+            <a:schemeClr val="phClr"/>
+          </a:solidFill>
+          <a:prstDash val="solid"/>
+          <a:miter lim="800000"/>
+        </a:ln>
+        <a:ln w="19050" cap="flat" cmpd="sng" algn="ctr">
+          <a:solidFill>
+            <a:schemeClr val="phClr"/>
+          </a:solidFill>
+          <a:prstDash val="solid"/>
+          <a:miter lim="800000"/>
+        </a:ln>
+        <a:ln w="25400" cap="flat" cmpd="sng" algn="ctr">
+          <a:solidFill>
+            <a:schemeClr val="phClr"/>
+          </a:solidFill>
+          <a:prstDash val="solid"/>
+          <a:miter lim="800000"/>
+        </a:ln>
+      </a:lnStyleLst>
+      <a:effectStyleLst>
+        <a:effectStyle>
+          <a:effectLst/>
+        </a:effectStyle>
+        <a:effectStyle>
+          <a:effectLst/>
+        </a:effectStyle>
+        <a:effectStyle>
+          <a:effectLst>
+            <a:outerShdw blurRad="57150" dist="19050" dir="5400000" algn="ctr" rotWithShape="0">
+              <a:srgbClr val="000000">
+                <a:alpha val="63000"/>
+              </a:srgbClr>
+            </a:outerShdw>
+          </a:effectLst>
+        </a:effectStyle>
+      </a:effectStyleLst>
+      <a:bgFillStyleLst>
+        <a:solidFill>
+          <a:schemeClr val="phClr"/>
+        </a:solidFill>
+        <a:solidFill>
+          <a:schemeClr val="phClr">
+            <a:tint val="95000"/>
+            <a:satMod val="170000"/>
+          </a:schemeClr>
+        </a:solidFill>
+        <a:gradFill rotWithShape="1">
+          <a:gsLst>
+            <a:gs pos="0">
+              <a:schemeClr val="phClr">
+                <a:tint val="93000"/>
+                <a:satMod val="150000"/>
+                <a:shade val="98000"/>
+                <a:lumMod val="102000"/>
+              </a:schemeClr>
+            </a:gs>
+            <a:gs pos="50000">
+              <a:schemeClr val="phClr">
+                <a:tint val="98000"/>
+                <a:satMod val="130000"/>
+                <a:shade val="90000"/>
+                <a:lumMod val="103000"/>
+              </a:schemeClr>
+            </a:gs>
+            <a:gs pos="100000">
+              <a:schemeClr val="phClr">
+                <a:shade val="63000"/>
+                <a:satMod val="120000"/>
+              </a:schemeClr>
+            </a:gs>
+          </a:gsLst>
+          <a:lin ang="5400000" scaled="0"/>
+        </a:gradFill>
+      </a:bgFillStyleLst>
+    </a:fmtScheme>
+  </a:themeElements>
+  <a:objectDefaults>
+    <a:lnDef>
+      <a:spPr/>
+      <a:bodyPr/>
+      <a:lstStyle/>
+      <a:style>
+        <a:lnRef idx="2">
+          <a:schemeClr val="accent1"/>
+        </a:lnRef>
+        <a:fillRef idx="0">
+          <a:schemeClr val="accent1"/>
+        </a:fillRef>
+        <a:effectRef idx="1">
+          <a:schemeClr val="accent1"/>
+        </a:effectRef>
+        <a:fontRef idx="minor">
+          <a:schemeClr val="tx1"/>
+        </a:fontRef>
+      </a:style>
+    </a:lnDef>
+  </a:objectDefaults>
+  <a:extraClrSchemeLst/>
+  <a:extLst>
+    <a:ext uri="{05A4C25C-085E-4340-85A3-A5531E510DB2}">
+      <thm15:themeFamily xmlns:thm15="http://schemas.microsoft.com/office/thememl/2012/main" name="Office Theme" id="{2E142A2C-CD16-42D6-873A-C26D2A0506FA}" vid="{1BDDFF52-6CD6-40A5-AB3C-68EB2F1E4D0A}"/>
+    </a:ext>
+  </a:extLst>
+</a:theme>
 </file>
</xml_diff>